<commit_message>
Melhora o layout dos slides do curso
Fonte calculada pela capacidade de cada caixa (o ajuste automático do
PowerPoint só age ao editar), margens padronizadas, listas longas em duas
colunas, números-chave em cartões de indicador, numeração de slides e
abertura de aula com número grande e etapa.

Co-Authored-By: Claude Opus 5.5 <noreply@anthropic.com>
</commit_message>
<xml_diff>
--- a/docs/curso/slides/m00-boas-vindas.pptx
+++ b/docs/curso/slides/m00-boas-vindas.pptx
@@ -2086,6 +2086,54 @@
           <a:chExt cx="0" cy="0"/>
         </a:xfrm>
       </p:grpSpPr>
+      <p:sp>
+        <p:nvSpPr>
+          <p:cNvPr id="25" name="Slide Number Placeholder 0"/>
+          <p:cNvSpPr>
+            <a:spLocks noGrp="1"/>
+          </p:cNvSpPr>
+          <p:nvPr>
+            <p:ph type="sldNum" sz="quarter" idx="4294967295"/>
+          </p:nvPr>
+        </p:nvSpPr>
+        <p:spPr>
+          <a:xfrm>
+            <a:off x="11292840" y="6556248"/>
+            <a:ext cx="548640" cy="256032"/>
+          </a:xfrm>
+          <a:prstGeom prst="rect">
+            <a:avLst/>
+          </a:prstGeom>
+          <a:extLst>
+            <a:ext uri="{C572A759-6A51-4108-AA02-DFA0A04FC94B}">
+              <ma14:wrappingTextBoxFlag xmlns:ma14="http://schemas.microsoft.com/office/mac/drawingml/2011/main" val="0"/>
+            </a:ext>
+          </a:extLst>
+        </p:spPr>
+        <p:txBody>
+          <a:bodyPr/>
+          <a:lstStyle>
+            <a:lvl1pPr>
+              <a:defRPr sz="900">
+                <a:solidFill>
+                  <a:srgbClr val="1B3A6B"/>
+                </a:solidFill>
+                <a:latin typeface="Arial"/>
+                <a:ea typeface="Arial"/>
+                <a:cs typeface="Arial"/>
+              </a:defRPr>
+            </a:lvl1pPr>
+          </a:lstStyle>
+          <a:p>
+            <a:pPr algn="r"/>
+            <a:fld id="{F7021451-1387-4CA6-816F-3879F97B5CBC}" type="slidenum">
+              <a:rPr b="1" lang="en-US"/>
+              <a:t>1000</a:t>
+            </a:fld>
+            <a:endParaRPr lang="en-US"/>
+          </a:p>
+        </p:txBody>
+      </p:sp>
     </p:spTree>
   </p:cSld>
   <p:clrMapOvr>
@@ -2111,6 +2159,54 @@
           <a:chExt cx="0" cy="0"/>
         </a:xfrm>
       </p:grpSpPr>
+      <p:sp>
+        <p:nvSpPr>
+          <p:cNvPr id="25" name="Slide Number Placeholder 0"/>
+          <p:cNvSpPr>
+            <a:spLocks noGrp="1"/>
+          </p:cNvSpPr>
+          <p:nvPr>
+            <p:ph type="sldNum" sz="quarter" idx="4294967295"/>
+          </p:nvPr>
+        </p:nvSpPr>
+        <p:spPr>
+          <a:xfrm>
+            <a:off x="11292840" y="6556248"/>
+            <a:ext cx="548640" cy="256032"/>
+          </a:xfrm>
+          <a:prstGeom prst="rect">
+            <a:avLst/>
+          </a:prstGeom>
+          <a:extLst>
+            <a:ext uri="{C572A759-6A51-4108-AA02-DFA0A04FC94B}">
+              <ma14:wrappingTextBoxFlag xmlns:ma14="http://schemas.microsoft.com/office/mac/drawingml/2011/main" val="0"/>
+            </a:ext>
+          </a:extLst>
+        </p:spPr>
+        <p:txBody>
+          <a:bodyPr/>
+          <a:lstStyle>
+            <a:lvl1pPr>
+              <a:defRPr sz="900">
+                <a:solidFill>
+                  <a:srgbClr val="1B3A6B"/>
+                </a:solidFill>
+                <a:latin typeface="Arial"/>
+                <a:ea typeface="Arial"/>
+                <a:cs typeface="Arial"/>
+              </a:defRPr>
+            </a:lvl1pPr>
+          </a:lstStyle>
+          <a:p>
+            <a:pPr algn="r"/>
+            <a:fld id="{F7021451-1387-4CA6-816F-3879F97B5CBC}" type="slidenum">
+              <a:rPr b="1" lang="en-US"/>
+              <a:t>null</a:t>
+            </a:fld>
+            <a:endParaRPr lang="en-US"/>
+          </a:p>
+        </p:txBody>
+      </p:sp>
     </p:spTree>
   </p:cSld>
   <p:clrMap bg1="lt1" tx1="dk1" bg2="lt2" tx2="dk2" accent1="accent1" accent2="accent2" accent3="accent3" accent4="accent4" accent5="accent5" accent6="accent6" hlink="hlink" folHlink="folHlink"/>
@@ -2873,6 +2969,45 @@
         </p:nvSpPr>
         <p:spPr>
           <a:xfrm>
+            <a:off x="457200" y="548640"/>
+            <a:ext cx="3474720" cy="1737360"/>
+          </a:xfrm>
+          <a:prstGeom prst="rect">
+            <a:avLst/>
+          </a:prstGeom>
+          <a:noFill/>
+          <a:ln/>
+        </p:spPr>
+        <p:txBody>
+          <a:bodyPr wrap="square" rtlCol="0" anchor="ctr"/>
+          <a:lstStyle/>
+          <a:p>
+            <a:pPr indent="0" marL="0">
+              <a:buNone/>
+            </a:pPr>
+            <a:r>
+              <a:rPr lang="en-US" sz="11000" b="1" dirty="0">
+                <a:solidFill>
+                  <a:srgbClr val="11396F"/>
+                </a:solidFill>
+                <a:latin typeface="Arial" pitchFamily="34" charset="0"/>
+                <a:ea typeface="Arial" pitchFamily="34" charset="-122"/>
+                <a:cs typeface="Arial" pitchFamily="34" charset="-120"/>
+              </a:rPr>
+              <a:t>03</a:t>
+            </a:r>
+            <a:endParaRPr lang="en-US" sz="11000" dirty="0"/>
+          </a:p>
+        </p:txBody>
+      </p:sp>
+      <p:sp>
+        <p:nvSpPr>
+          <p:cNvPr id="4" name="Text 2"/>
+          <p:cNvSpPr/>
+          <p:nvPr/>
+        </p:nvSpPr>
+        <p:spPr>
+          <a:xfrm>
             <a:off x="548640" y="2194560"/>
             <a:ext cx="3291840" cy="548640"/>
           </a:xfrm>
@@ -2906,7 +3041,46 @@
       </p:sp>
       <p:sp>
         <p:nvSpPr>
-          <p:cNvPr id="4" name="Text 2"/>
+          <p:cNvPr id="5" name="Text 3"/>
+          <p:cNvSpPr/>
+          <p:nvPr/>
+        </p:nvSpPr>
+        <p:spPr>
+          <a:xfrm>
+            <a:off x="548640" y="3200400"/>
+            <a:ext cx="3383280" cy="457200"/>
+          </a:xfrm>
+          <a:prstGeom prst="rect">
+            <a:avLst/>
+          </a:prstGeom>
+          <a:noFill/>
+          <a:ln/>
+        </p:spPr>
+        <p:txBody>
+          <a:bodyPr wrap="square" rtlCol="0" anchor="ctr"/>
+          <a:lstStyle/>
+          <a:p>
+            <a:pPr indent="0" marL="0">
+              <a:buNone/>
+            </a:pPr>
+            <a:r>
+              <a:rPr lang="en-US" sz="1100" dirty="0">
+                <a:solidFill>
+                  <a:srgbClr val="C7D2E3"/>
+                </a:solidFill>
+                <a:latin typeface="Arial" pitchFamily="34" charset="0"/>
+                <a:ea typeface="Arial" pitchFamily="34" charset="-122"/>
+                <a:cs typeface="Arial" pitchFamily="34" charset="-120"/>
+              </a:rPr>
+              <a:t>M0 · Etapa 1 · Fundamentos</a:t>
+            </a:r>
+            <a:endParaRPr lang="en-US" sz="1100" dirty="0"/>
+          </a:p>
+        </p:txBody>
+      </p:sp>
+      <p:sp>
+        <p:nvSpPr>
+          <p:cNvPr id="6" name="Text 4"/>
           <p:cNvSpPr/>
           <p:nvPr/>
         </p:nvSpPr>
@@ -2945,7 +3119,7 @@
       </p:sp>
       <p:pic>
         <p:nvPicPr>
-          <p:cNvPr id="5" name="Image 0" descr="/www/wwwroot/rexar/gdsolar/docs/curso/slides/assets/logo-gdsolar.png">    </p:cNvPr>
+          <p:cNvPr id="7" name="Image 0" descr="/www/wwwroot/rexar/gdsolar/docs/curso/slides/assets/logo-gdsolar.png">    </p:cNvPr>
           <p:cNvPicPr>
             <a:picLocks noChangeAspect="1"/>
           </p:cNvPicPr>
@@ -2969,7 +3143,7 @@
       </p:pic>
       <p:sp>
         <p:nvSpPr>
-          <p:cNvPr id="6" name="Text 3"/>
+          <p:cNvPr id="8" name="Text 5"/>
           <p:cNvSpPr/>
           <p:nvPr/>
         </p:nvSpPr>
@@ -3010,7 +3184,7 @@
       </p:sp>
       <p:sp>
         <p:nvSpPr>
-          <p:cNvPr id="7" name="Text 4"/>
+          <p:cNvPr id="9" name="Text 6"/>
           <p:cNvSpPr/>
           <p:nvPr/>
         </p:nvSpPr>
@@ -3051,7 +3225,7 @@
       </p:sp>
       <p:sp>
         <p:nvSpPr>
-          <p:cNvPr id="8" name="Text 5"/>
+          <p:cNvPr id="10" name="Text 7"/>
           <p:cNvSpPr/>
           <p:nvPr/>
         </p:nvSpPr>
@@ -3167,7 +3341,7 @@
         </p:blipFill>
         <p:spPr>
           <a:xfrm>
-            <a:off x="411480" y="6547104"/>
+            <a:off x="548640" y="6547104"/>
             <a:ext cx="274320" cy="274320"/>
           </a:xfrm>
           <a:prstGeom prst="rect">
@@ -3183,7 +3357,7 @@
         </p:nvSpPr>
         <p:spPr>
           <a:xfrm>
-            <a:off x="749808" y="6528816"/>
+            <a:off x="886968" y="6528816"/>
             <a:ext cx="6400800" cy="310896"/>
           </a:xfrm>
           <a:prstGeom prst="rect">
@@ -3223,7 +3397,7 @@
         <p:spPr>
           <a:xfrm>
             <a:off x="7132320" y="6528816"/>
-            <a:ext cx="4663440" cy="310896"/>
+            <a:ext cx="4023360" cy="310896"/>
           </a:xfrm>
           <a:prstGeom prst="rect">
             <a:avLst/>
@@ -3261,7 +3435,7 @@
         </p:nvSpPr>
         <p:spPr>
           <a:xfrm>
-            <a:off x="411480" y="384048"/>
+            <a:off x="548640" y="384048"/>
             <a:ext cx="82296" cy="658368"/>
           </a:xfrm>
           <a:prstGeom prst="rect">
@@ -3281,7 +3455,7 @@
         </p:nvSpPr>
         <p:spPr>
           <a:xfrm>
-            <a:off x="640080" y="292608"/>
+            <a:off x="777240" y="292608"/>
             <a:ext cx="10972800" cy="274320"/>
           </a:xfrm>
           <a:prstGeom prst="rect">
@@ -3320,8 +3494,8 @@
         </p:nvSpPr>
         <p:spPr>
           <a:xfrm>
-            <a:off x="640080" y="530352"/>
-            <a:ext cx="11155680" cy="566928"/>
+            <a:off x="777240" y="530352"/>
+            <a:ext cx="10881360" cy="566928"/>
           </a:xfrm>
           <a:prstGeom prst="rect">
             <a:avLst/>
@@ -3675,6 +3849,54 @@
               <a:t>Cliente = assinante: vê faturas, cobranças e economia</a:t>
             </a:r>
             <a:endParaRPr lang="en-US" sz="1500" dirty="0"/>
+          </a:p>
+        </p:txBody>
+      </p:sp>
+      <p:sp>
+        <p:nvSpPr>
+          <p:cNvPr id="25" name="Slide Number Placeholder 0"/>
+          <p:cNvSpPr>
+            <a:spLocks noGrp="1"/>
+          </p:cNvSpPr>
+          <p:nvPr>
+            <p:ph type="sldNum" sz="quarter" idx="4294967295"/>
+          </p:nvPr>
+        </p:nvSpPr>
+        <p:spPr>
+          <a:xfrm>
+            <a:off x="11292840" y="6556248"/>
+            <a:ext cx="548640" cy="256032"/>
+          </a:xfrm>
+          <a:prstGeom prst="rect">
+            <a:avLst/>
+          </a:prstGeom>
+          <a:extLst>
+            <a:ext uri="{C572A759-6A51-4108-AA02-DFA0A04FC94B}">
+              <ma14:wrappingTextBoxFlag xmlns:ma14="http://schemas.microsoft.com/office/mac/drawingml/2011/main" val="0"/>
+            </a:ext>
+          </a:extLst>
+        </p:spPr>
+        <p:txBody>
+          <a:bodyPr/>
+          <a:lstStyle>
+            <a:lvl1pPr>
+              <a:defRPr sz="900">
+                <a:solidFill>
+                  <a:srgbClr val="1B3A6B"/>
+                </a:solidFill>
+                <a:latin typeface="Arial"/>
+                <a:ea typeface="Arial"/>
+                <a:cs typeface="Arial"/>
+              </a:defRPr>
+            </a:lvl1pPr>
+          </a:lstStyle>
+          <a:p>
+            <a:pPr algn="r"/>
+            <a:fld id="{F7021451-1387-4CA6-816F-3879F97B5CBC}" type="slidenum">
+              <a:rPr b="1" lang="en-US"/>
+              <a:t>11</a:t>
+            </a:fld>
+            <a:endParaRPr lang="en-US"/>
           </a:p>
         </p:txBody>
       </p:sp>
@@ -3751,7 +3973,7 @@
         </p:blipFill>
         <p:spPr>
           <a:xfrm>
-            <a:off x="411480" y="6547104"/>
+            <a:off x="548640" y="6547104"/>
             <a:ext cx="274320" cy="274320"/>
           </a:xfrm>
           <a:prstGeom prst="rect">
@@ -3767,7 +3989,7 @@
         </p:nvSpPr>
         <p:spPr>
           <a:xfrm>
-            <a:off x="749808" y="6528816"/>
+            <a:off x="886968" y="6528816"/>
             <a:ext cx="6400800" cy="310896"/>
           </a:xfrm>
           <a:prstGeom prst="rect">
@@ -3807,7 +4029,7 @@
         <p:spPr>
           <a:xfrm>
             <a:off x="7132320" y="6528816"/>
-            <a:ext cx="4663440" cy="310896"/>
+            <a:ext cx="4023360" cy="310896"/>
           </a:xfrm>
           <a:prstGeom prst="rect">
             <a:avLst/>
@@ -3845,7 +4067,7 @@
         </p:nvSpPr>
         <p:spPr>
           <a:xfrm>
-            <a:off x="411480" y="384048"/>
+            <a:off x="548640" y="384048"/>
             <a:ext cx="82296" cy="658368"/>
           </a:xfrm>
           <a:prstGeom prst="rect">
@@ -3865,7 +4087,7 @@
         </p:nvSpPr>
         <p:spPr>
           <a:xfrm>
-            <a:off x="640080" y="292608"/>
+            <a:off x="777240" y="292608"/>
             <a:ext cx="10972800" cy="274320"/>
           </a:xfrm>
           <a:prstGeom prst="rect">
@@ -3904,8 +4126,8 @@
         </p:nvSpPr>
         <p:spPr>
           <a:xfrm>
-            <a:off x="640080" y="530352"/>
-            <a:ext cx="11155680" cy="566928"/>
+            <a:off x="777240" y="530352"/>
+            <a:ext cx="10881360" cy="566928"/>
           </a:xfrm>
           <a:prstGeom prst="rect">
             <a:avLst/>
@@ -4106,6 +4328,54 @@
               <a:t>Produtor = dono da usina: vê suas usinas e a geração</a:t>
             </a:r>
             <a:endParaRPr lang="en-US" sz="1500" dirty="0"/>
+          </a:p>
+        </p:txBody>
+      </p:sp>
+      <p:sp>
+        <p:nvSpPr>
+          <p:cNvPr id="25" name="Slide Number Placeholder 0"/>
+          <p:cNvSpPr>
+            <a:spLocks noGrp="1"/>
+          </p:cNvSpPr>
+          <p:nvPr>
+            <p:ph type="sldNum" sz="quarter" idx="4294967295"/>
+          </p:nvPr>
+        </p:nvSpPr>
+        <p:spPr>
+          <a:xfrm>
+            <a:off x="11292840" y="6556248"/>
+            <a:ext cx="548640" cy="256032"/>
+          </a:xfrm>
+          <a:prstGeom prst="rect">
+            <a:avLst/>
+          </a:prstGeom>
+          <a:extLst>
+            <a:ext uri="{C572A759-6A51-4108-AA02-DFA0A04FC94B}">
+              <ma14:wrappingTextBoxFlag xmlns:ma14="http://schemas.microsoft.com/office/mac/drawingml/2011/main" val="0"/>
+            </a:ext>
+          </a:extLst>
+        </p:spPr>
+        <p:txBody>
+          <a:bodyPr/>
+          <a:lstStyle>
+            <a:lvl1pPr>
+              <a:defRPr sz="900">
+                <a:solidFill>
+                  <a:srgbClr val="1B3A6B"/>
+                </a:solidFill>
+                <a:latin typeface="Arial"/>
+                <a:ea typeface="Arial"/>
+                <a:cs typeface="Arial"/>
+              </a:defRPr>
+            </a:lvl1pPr>
+          </a:lstStyle>
+          <a:p>
+            <a:pPr algn="r"/>
+            <a:fld id="{F7021451-1387-4CA6-816F-3879F97B5CBC}" type="slidenum">
+              <a:rPr b="1" lang="en-US"/>
+              <a:t>12</a:t>
+            </a:fld>
+            <a:endParaRPr lang="en-US"/>
           </a:p>
         </p:txBody>
       </p:sp>
@@ -4182,7 +4452,7 @@
         </p:blipFill>
         <p:spPr>
           <a:xfrm>
-            <a:off x="411480" y="6547104"/>
+            <a:off x="548640" y="6547104"/>
             <a:ext cx="274320" cy="274320"/>
           </a:xfrm>
           <a:prstGeom prst="rect">
@@ -4198,7 +4468,7 @@
         </p:nvSpPr>
         <p:spPr>
           <a:xfrm>
-            <a:off x="749808" y="6528816"/>
+            <a:off x="886968" y="6528816"/>
             <a:ext cx="6400800" cy="310896"/>
           </a:xfrm>
           <a:prstGeom prst="rect">
@@ -4238,7 +4508,7 @@
         <p:spPr>
           <a:xfrm>
             <a:off x="7132320" y="6528816"/>
-            <a:ext cx="4663440" cy="310896"/>
+            <a:ext cx="4023360" cy="310896"/>
           </a:xfrm>
           <a:prstGeom prst="rect">
             <a:avLst/>
@@ -4276,7 +4546,7 @@
         </p:nvSpPr>
         <p:spPr>
           <a:xfrm>
-            <a:off x="411480" y="384048"/>
+            <a:off x="548640" y="384048"/>
             <a:ext cx="82296" cy="658368"/>
           </a:xfrm>
           <a:prstGeom prst="rect">
@@ -4296,7 +4566,7 @@
         </p:nvSpPr>
         <p:spPr>
           <a:xfrm>
-            <a:off x="640080" y="292608"/>
+            <a:off x="777240" y="292608"/>
             <a:ext cx="10972800" cy="274320"/>
           </a:xfrm>
           <a:prstGeom prst="rect">
@@ -4335,8 +4605,8 @@
         </p:nvSpPr>
         <p:spPr>
           <a:xfrm>
-            <a:off x="640080" y="530352"/>
-            <a:ext cx="11155680" cy="566928"/>
+            <a:off x="777240" y="530352"/>
+            <a:ext cx="10881360" cy="566928"/>
           </a:xfrm>
           <a:prstGeom prst="rect">
             <a:avLst/>
@@ -4426,6 +4696,54 @@
           </a:prstGeom>
         </p:spPr>
       </p:pic>
+      <p:sp>
+        <p:nvSpPr>
+          <p:cNvPr id="25" name="Slide Number Placeholder 0"/>
+          <p:cNvSpPr>
+            <a:spLocks noGrp="1"/>
+          </p:cNvSpPr>
+          <p:nvPr>
+            <p:ph type="sldNum" sz="quarter" idx="4294967295"/>
+          </p:nvPr>
+        </p:nvSpPr>
+        <p:spPr>
+          <a:xfrm>
+            <a:off x="11292840" y="6556248"/>
+            <a:ext cx="548640" cy="256032"/>
+          </a:xfrm>
+          <a:prstGeom prst="rect">
+            <a:avLst/>
+          </a:prstGeom>
+          <a:extLst>
+            <a:ext uri="{C572A759-6A51-4108-AA02-DFA0A04FC94B}">
+              <ma14:wrappingTextBoxFlag xmlns:ma14="http://schemas.microsoft.com/office/mac/drawingml/2011/main" val="0"/>
+            </a:ext>
+          </a:extLst>
+        </p:spPr>
+        <p:txBody>
+          <a:bodyPr/>
+          <a:lstStyle>
+            <a:lvl1pPr>
+              <a:defRPr sz="900">
+                <a:solidFill>
+                  <a:srgbClr val="1B3A6B"/>
+                </a:solidFill>
+                <a:latin typeface="Arial"/>
+                <a:ea typeface="Arial"/>
+                <a:cs typeface="Arial"/>
+              </a:defRPr>
+            </a:lvl1pPr>
+          </a:lstStyle>
+          <a:p>
+            <a:pPr algn="r"/>
+            <a:fld id="{F7021451-1387-4CA6-816F-3879F97B5CBC}" type="slidenum">
+              <a:rPr b="1" lang="en-US"/>
+              <a:t>13</a:t>
+            </a:fld>
+            <a:endParaRPr lang="en-US"/>
+          </a:p>
+        </p:txBody>
+      </p:sp>
     </p:spTree>
   </p:cSld>
   <p:clrMapOvr>
@@ -4499,7 +4817,7 @@
         </p:blipFill>
         <p:spPr>
           <a:xfrm>
-            <a:off x="411480" y="6547104"/>
+            <a:off x="548640" y="6547104"/>
             <a:ext cx="274320" cy="274320"/>
           </a:xfrm>
           <a:prstGeom prst="rect">
@@ -4515,7 +4833,7 @@
         </p:nvSpPr>
         <p:spPr>
           <a:xfrm>
-            <a:off x="749808" y="6528816"/>
+            <a:off x="886968" y="6528816"/>
             <a:ext cx="6400800" cy="310896"/>
           </a:xfrm>
           <a:prstGeom prst="rect">
@@ -4555,7 +4873,7 @@
         <p:spPr>
           <a:xfrm>
             <a:off x="7132320" y="6528816"/>
-            <a:ext cx="4663440" cy="310896"/>
+            <a:ext cx="4023360" cy="310896"/>
           </a:xfrm>
           <a:prstGeom prst="rect">
             <a:avLst/>
@@ -4593,7 +4911,7 @@
         </p:nvSpPr>
         <p:spPr>
           <a:xfrm>
-            <a:off x="411480" y="384048"/>
+            <a:off x="548640" y="384048"/>
             <a:ext cx="82296" cy="658368"/>
           </a:xfrm>
           <a:prstGeom prst="rect">
@@ -4613,7 +4931,7 @@
         </p:nvSpPr>
         <p:spPr>
           <a:xfrm>
-            <a:off x="640080" y="292608"/>
+            <a:off x="777240" y="292608"/>
             <a:ext cx="10972800" cy="274320"/>
           </a:xfrm>
           <a:prstGeom prst="rect">
@@ -4652,8 +4970,8 @@
         </p:nvSpPr>
         <p:spPr>
           <a:xfrm>
-            <a:off x="640080" y="530352"/>
-            <a:ext cx="11155680" cy="566928"/>
+            <a:off x="777240" y="530352"/>
+            <a:ext cx="10881360" cy="566928"/>
           </a:xfrm>
           <a:prstGeom prst="rect">
             <a:avLst/>
@@ -4743,6 +5061,54 @@
           </a:prstGeom>
         </p:spPr>
       </p:pic>
+      <p:sp>
+        <p:nvSpPr>
+          <p:cNvPr id="25" name="Slide Number Placeholder 0"/>
+          <p:cNvSpPr>
+            <a:spLocks noGrp="1"/>
+          </p:cNvSpPr>
+          <p:nvPr>
+            <p:ph type="sldNum" sz="quarter" idx="4294967295"/>
+          </p:nvPr>
+        </p:nvSpPr>
+        <p:spPr>
+          <a:xfrm>
+            <a:off x="11292840" y="6556248"/>
+            <a:ext cx="548640" cy="256032"/>
+          </a:xfrm>
+          <a:prstGeom prst="rect">
+            <a:avLst/>
+          </a:prstGeom>
+          <a:extLst>
+            <a:ext uri="{C572A759-6A51-4108-AA02-DFA0A04FC94B}">
+              <ma14:wrappingTextBoxFlag xmlns:ma14="http://schemas.microsoft.com/office/mac/drawingml/2011/main" val="0"/>
+            </a:ext>
+          </a:extLst>
+        </p:spPr>
+        <p:txBody>
+          <a:bodyPr/>
+          <a:lstStyle>
+            <a:lvl1pPr>
+              <a:defRPr sz="900">
+                <a:solidFill>
+                  <a:srgbClr val="1B3A6B"/>
+                </a:solidFill>
+                <a:latin typeface="Arial"/>
+                <a:ea typeface="Arial"/>
+                <a:cs typeface="Arial"/>
+              </a:defRPr>
+            </a:lvl1pPr>
+          </a:lstStyle>
+          <a:p>
+            <a:pPr algn="r"/>
+            <a:fld id="{F7021451-1387-4CA6-816F-3879F97B5CBC}" type="slidenum">
+              <a:rPr b="1" lang="en-US"/>
+              <a:t>14</a:t>
+            </a:fld>
+            <a:endParaRPr lang="en-US"/>
+          </a:p>
+        </p:txBody>
+      </p:sp>
     </p:spTree>
   </p:cSld>
   <p:clrMapOvr>
@@ -4803,6 +5169,45 @@
         </p:nvSpPr>
         <p:spPr>
           <a:xfrm>
+            <a:off x="457200" y="548640"/>
+            <a:ext cx="3474720" cy="1737360"/>
+          </a:xfrm>
+          <a:prstGeom prst="rect">
+            <a:avLst/>
+          </a:prstGeom>
+          <a:noFill/>
+          <a:ln/>
+        </p:spPr>
+        <p:txBody>
+          <a:bodyPr wrap="square" rtlCol="0" anchor="ctr"/>
+          <a:lstStyle/>
+          <a:p>
+            <a:pPr indent="0" marL="0">
+              <a:buNone/>
+            </a:pPr>
+            <a:r>
+              <a:rPr lang="en-US" sz="11000" b="1" dirty="0">
+                <a:solidFill>
+                  <a:srgbClr val="11396F"/>
+                </a:solidFill>
+                <a:latin typeface="Arial" pitchFamily="34" charset="0"/>
+                <a:ea typeface="Arial" pitchFamily="34" charset="-122"/>
+                <a:cs typeface="Arial" pitchFamily="34" charset="-120"/>
+              </a:rPr>
+              <a:t>04</a:t>
+            </a:r>
+            <a:endParaRPr lang="en-US" sz="11000" dirty="0"/>
+          </a:p>
+        </p:txBody>
+      </p:sp>
+      <p:sp>
+        <p:nvSpPr>
+          <p:cNvPr id="4" name="Text 2"/>
+          <p:cNvSpPr/>
+          <p:nvPr/>
+        </p:nvSpPr>
+        <p:spPr>
+          <a:xfrm>
             <a:off x="548640" y="2194560"/>
             <a:ext cx="3291840" cy="548640"/>
           </a:xfrm>
@@ -4836,7 +5241,46 @@
       </p:sp>
       <p:sp>
         <p:nvSpPr>
-          <p:cNvPr id="4" name="Text 2"/>
+          <p:cNvPr id="5" name="Text 3"/>
+          <p:cNvSpPr/>
+          <p:nvPr/>
+        </p:nvSpPr>
+        <p:spPr>
+          <a:xfrm>
+            <a:off x="548640" y="3200400"/>
+            <a:ext cx="3383280" cy="457200"/>
+          </a:xfrm>
+          <a:prstGeom prst="rect">
+            <a:avLst/>
+          </a:prstGeom>
+          <a:noFill/>
+          <a:ln/>
+        </p:spPr>
+        <p:txBody>
+          <a:bodyPr wrap="square" rtlCol="0" anchor="ctr"/>
+          <a:lstStyle/>
+          <a:p>
+            <a:pPr indent="0" marL="0">
+              <a:buNone/>
+            </a:pPr>
+            <a:r>
+              <a:rPr lang="en-US" sz="1100" dirty="0">
+                <a:solidFill>
+                  <a:srgbClr val="C7D2E3"/>
+                </a:solidFill>
+                <a:latin typeface="Arial" pitchFamily="34" charset="0"/>
+                <a:ea typeface="Arial" pitchFamily="34" charset="-122"/>
+                <a:cs typeface="Arial" pitchFamily="34" charset="-120"/>
+              </a:rPr>
+              <a:t>M0 · Etapa 1 · Fundamentos</a:t>
+            </a:r>
+            <a:endParaRPr lang="en-US" sz="1100" dirty="0"/>
+          </a:p>
+        </p:txBody>
+      </p:sp>
+      <p:sp>
+        <p:nvSpPr>
+          <p:cNvPr id="6" name="Text 4"/>
           <p:cNvSpPr/>
           <p:nvPr/>
         </p:nvSpPr>
@@ -4875,7 +5319,7 @@
       </p:sp>
       <p:pic>
         <p:nvPicPr>
-          <p:cNvPr id="5" name="Image 0" descr="/www/wwwroot/rexar/gdsolar/docs/curso/slides/assets/logo-gdsolar.png">    </p:cNvPr>
+          <p:cNvPr id="7" name="Image 0" descr="/www/wwwroot/rexar/gdsolar/docs/curso/slides/assets/logo-gdsolar.png">    </p:cNvPr>
           <p:cNvPicPr>
             <a:picLocks noChangeAspect="1"/>
           </p:cNvPicPr>
@@ -4899,7 +5343,7 @@
       </p:pic>
       <p:sp>
         <p:nvSpPr>
-          <p:cNvPr id="6" name="Text 3"/>
+          <p:cNvPr id="8" name="Text 5"/>
           <p:cNvSpPr/>
           <p:nvPr/>
         </p:nvSpPr>
@@ -4940,7 +5384,7 @@
       </p:sp>
       <p:sp>
         <p:nvSpPr>
-          <p:cNvPr id="7" name="Text 4"/>
+          <p:cNvPr id="9" name="Text 6"/>
           <p:cNvSpPr/>
           <p:nvPr/>
         </p:nvSpPr>
@@ -4981,7 +5425,7 @@
       </p:sp>
       <p:sp>
         <p:nvSpPr>
-          <p:cNvPr id="8" name="Text 5"/>
+          <p:cNvPr id="10" name="Text 7"/>
           <p:cNvSpPr/>
           <p:nvPr/>
         </p:nvSpPr>
@@ -5160,7 +5604,7 @@
         </p:blipFill>
         <p:spPr>
           <a:xfrm>
-            <a:off x="411480" y="6547104"/>
+            <a:off x="548640" y="6547104"/>
             <a:ext cx="274320" cy="274320"/>
           </a:xfrm>
           <a:prstGeom prst="rect">
@@ -5176,7 +5620,7 @@
         </p:nvSpPr>
         <p:spPr>
           <a:xfrm>
-            <a:off x="749808" y="6528816"/>
+            <a:off x="886968" y="6528816"/>
             <a:ext cx="6400800" cy="310896"/>
           </a:xfrm>
           <a:prstGeom prst="rect">
@@ -5216,7 +5660,7 @@
         <p:spPr>
           <a:xfrm>
             <a:off x="7132320" y="6528816"/>
-            <a:ext cx="4663440" cy="310896"/>
+            <a:ext cx="4023360" cy="310896"/>
           </a:xfrm>
           <a:prstGeom prst="rect">
             <a:avLst/>
@@ -5254,7 +5698,7 @@
         </p:nvSpPr>
         <p:spPr>
           <a:xfrm>
-            <a:off x="411480" y="384048"/>
+            <a:off x="548640" y="384048"/>
             <a:ext cx="82296" cy="658368"/>
           </a:xfrm>
           <a:prstGeom prst="rect">
@@ -5274,7 +5718,7 @@
         </p:nvSpPr>
         <p:spPr>
           <a:xfrm>
-            <a:off x="640080" y="292608"/>
+            <a:off x="777240" y="292608"/>
             <a:ext cx="10972800" cy="274320"/>
           </a:xfrm>
           <a:prstGeom prst="rect">
@@ -5313,8 +5757,8 @@
         </p:nvSpPr>
         <p:spPr>
           <a:xfrm>
-            <a:off x="640080" y="530352"/>
-            <a:ext cx="11155680" cy="566928"/>
+            <a:off x="777240" y="530352"/>
+            <a:ext cx="10881360" cy="566928"/>
           </a:xfrm>
           <a:prstGeom prst="rect">
             <a:avLst/>
@@ -5354,12 +5798,12 @@
         </p:nvSpPr>
         <p:spPr>
           <a:xfrm>
-            <a:off x="411480" y="1325880"/>
-            <a:ext cx="3611880" cy="4937760"/>
+            <a:off x="548640" y="1325880"/>
+            <a:ext cx="3514344" cy="4937760"/>
           </a:xfrm>
           <a:prstGeom prst="roundRect">
             <a:avLst>
-              <a:gd name="adj" fmla="val 2025"/>
+              <a:gd name="adj" fmla="val 2082"/>
             </a:avLst>
           </a:prstGeom>
           <a:solidFill>
@@ -5388,8 +5832,8 @@
         </p:nvSpPr>
         <p:spPr>
           <a:xfrm>
-            <a:off x="411480" y="1325880"/>
-            <a:ext cx="3611880" cy="109728"/>
+            <a:off x="548640" y="1325880"/>
+            <a:ext cx="3514344" cy="109728"/>
           </a:xfrm>
           <a:prstGeom prst="rect">
             <a:avLst/>
@@ -5408,8 +5852,8 @@
         </p:nvSpPr>
         <p:spPr>
           <a:xfrm>
-            <a:off x="685800" y="1554480"/>
-            <a:ext cx="3063240" cy="685800"/>
+            <a:off x="822960" y="1554480"/>
+            <a:ext cx="2965704" cy="685800"/>
           </a:xfrm>
           <a:prstGeom prst="rect">
             <a:avLst/>
@@ -5449,8 +5893,8 @@
         </p:nvSpPr>
         <p:spPr>
           <a:xfrm>
-            <a:off x="685800" y="2286000"/>
-            <a:ext cx="3063240" cy="3749040"/>
+            <a:off x="822960" y="2286000"/>
+            <a:ext cx="2965704" cy="3749040"/>
           </a:xfrm>
           <a:prstGeom prst="rect">
             <a:avLst/>
@@ -5536,12 +5980,12 @@
         </p:nvSpPr>
         <p:spPr>
           <a:xfrm>
-            <a:off x="4297680" y="1325880"/>
-            <a:ext cx="3611880" cy="4937760"/>
+            <a:off x="4337304" y="1325880"/>
+            <a:ext cx="3514344" cy="4937760"/>
           </a:xfrm>
           <a:prstGeom prst="roundRect">
             <a:avLst>
-              <a:gd name="adj" fmla="val 2025"/>
+              <a:gd name="adj" fmla="val 2082"/>
             </a:avLst>
           </a:prstGeom>
           <a:solidFill>
@@ -5570,8 +6014,8 @@
         </p:nvSpPr>
         <p:spPr>
           <a:xfrm>
-            <a:off x="4297680" y="1325880"/>
-            <a:ext cx="3611880" cy="109728"/>
+            <a:off x="4337304" y="1325880"/>
+            <a:ext cx="3514344" cy="109728"/>
           </a:xfrm>
           <a:prstGeom prst="rect">
             <a:avLst/>
@@ -5590,8 +6034,8 @@
         </p:nvSpPr>
         <p:spPr>
           <a:xfrm>
-            <a:off x="4572000" y="1554480"/>
-            <a:ext cx="3063240" cy="685800"/>
+            <a:off x="4611624" y="1554480"/>
+            <a:ext cx="2965704" cy="685800"/>
           </a:xfrm>
           <a:prstGeom prst="rect">
             <a:avLst/>
@@ -5631,8 +6075,8 @@
         </p:nvSpPr>
         <p:spPr>
           <a:xfrm>
-            <a:off x="4572000" y="2286000"/>
-            <a:ext cx="3063240" cy="3749040"/>
+            <a:off x="4611624" y="2286000"/>
+            <a:ext cx="2965704" cy="3749040"/>
           </a:xfrm>
           <a:prstGeom prst="rect">
             <a:avLst/>
@@ -5654,7 +6098,7 @@
               <a:buChar char="●"/>
             </a:pPr>
             <a:r>
-              <a:rPr lang="en-US" sz="1300" dirty="0">
+              <a:rPr lang="en-US" sz="1700" dirty="0">
                 <a:solidFill>
                   <a:srgbClr val="1F2937"/>
                 </a:solidFill>
@@ -5664,7 +6108,7 @@
               </a:rPr>
               <a:t>- Nome da empresa (fictício)</a:t>
             </a:r>
-            <a:endParaRPr lang="en-US" sz="1300" dirty="0"/>
+            <a:endParaRPr lang="en-US" sz="1700" dirty="0"/>
           </a:p>
           <a:p>
             <a:pPr marL="342900" indent="-342900">
@@ -5675,7 +6119,7 @@
               <a:buChar char="●"/>
             </a:pPr>
             <a:r>
-              <a:rPr lang="en-US" sz="1300" dirty="0">
+              <a:rPr lang="en-US" sz="1700" dirty="0">
                 <a:solidFill>
                   <a:srgbClr val="1F2937"/>
                 </a:solidFill>
@@ -5685,7 +6129,7 @@
               </a:rPr>
               <a:t>- Cidade e estado de atuação</a:t>
             </a:r>
-            <a:endParaRPr lang="en-US" sz="1300" dirty="0"/>
+            <a:endParaRPr lang="en-US" sz="1700" dirty="0"/>
           </a:p>
           <a:p>
             <a:pPr marL="342900" indent="-342900">
@@ -5696,7 +6140,7 @@
               <a:buChar char="●"/>
             </a:pPr>
             <a:r>
-              <a:rPr lang="en-US" sz="1300" dirty="0">
+              <a:rPr lang="en-US" sz="1700" dirty="0">
                 <a:solidFill>
                   <a:srgbClr val="1F2937"/>
                 </a:solidFill>
@@ -5706,7 +6150,7 @@
               </a:rPr>
               <a:t>- Distribuidora da região</a:t>
             </a:r>
-            <a:endParaRPr lang="en-US" sz="1300" dirty="0"/>
+            <a:endParaRPr lang="en-US" sz="1700" dirty="0"/>
           </a:p>
           <a:p>
             <a:pPr marL="342900" indent="-342900">
@@ -5717,7 +6161,7 @@
               <a:buChar char="●"/>
             </a:pPr>
             <a:r>
-              <a:rPr lang="en-US" sz="1300" dirty="0">
+              <a:rPr lang="en-US" sz="1700" dirty="0">
                 <a:solidFill>
                   <a:srgbClr val="1F2937"/>
                 </a:solidFill>
@@ -5727,7 +6171,7 @@
               </a:rPr>
               <a:t>- Perfil: começando do zero / já tenho empresa solar</a:t>
             </a:r>
-            <a:endParaRPr lang="en-US" sz="1300" dirty="0"/>
+            <a:endParaRPr lang="en-US" sz="1700" dirty="0"/>
           </a:p>
           <a:p>
             <a:pPr marL="342900" indent="-342900">
@@ -5738,7 +6182,7 @@
               <a:buChar char="●"/>
             </a:pPr>
             <a:r>
-              <a:rPr lang="en-US" sz="1300" dirty="0">
+              <a:rPr lang="en-US" sz="1700" dirty="0">
                 <a:solidFill>
                   <a:srgbClr val="1F2937"/>
                 </a:solidFill>
@@ -5748,7 +6192,7 @@
               </a:rPr>
               <a:t>- Meta de 12 meses: usinas, clientes, kWh</a:t>
             </a:r>
-            <a:endParaRPr lang="en-US" sz="1300" dirty="0"/>
+            <a:endParaRPr lang="en-US" sz="1700" dirty="0"/>
           </a:p>
         </p:txBody>
       </p:sp>
@@ -5760,12 +6204,12 @@
         </p:nvSpPr>
         <p:spPr>
           <a:xfrm>
-            <a:off x="8183880" y="1325880"/>
-            <a:ext cx="3611880" cy="4937760"/>
+            <a:off x="8125968" y="1325880"/>
+            <a:ext cx="3514344" cy="4937760"/>
           </a:xfrm>
           <a:prstGeom prst="roundRect">
             <a:avLst>
-              <a:gd name="adj" fmla="val 2025"/>
+              <a:gd name="adj" fmla="val 2082"/>
             </a:avLst>
           </a:prstGeom>
           <a:solidFill>
@@ -5794,8 +6238,8 @@
         </p:nvSpPr>
         <p:spPr>
           <a:xfrm>
-            <a:off x="8183880" y="1325880"/>
-            <a:ext cx="3611880" cy="109728"/>
+            <a:off x="8125968" y="1325880"/>
+            <a:ext cx="3514344" cy="109728"/>
           </a:xfrm>
           <a:prstGeom prst="rect">
             <a:avLst/>
@@ -5814,8 +6258,8 @@
         </p:nvSpPr>
         <p:spPr>
           <a:xfrm>
-            <a:off x="8458200" y="1554480"/>
-            <a:ext cx="3063240" cy="685800"/>
+            <a:off x="8400288" y="1554480"/>
+            <a:ext cx="2965704" cy="685800"/>
           </a:xfrm>
           <a:prstGeom prst="rect">
             <a:avLst/>
@@ -5855,8 +6299,8 @@
         </p:nvSpPr>
         <p:spPr>
           <a:xfrm>
-            <a:off x="8458200" y="2286000"/>
-            <a:ext cx="3063240" cy="3749040"/>
+            <a:off x="8400288" y="2286000"/>
+            <a:ext cx="2965704" cy="3749040"/>
           </a:xfrm>
           <a:prstGeom prst="rect">
             <a:avLst/>
@@ -5878,7 +6322,7 @@
               <a:buChar char="●"/>
             </a:pPr>
             <a:r>
-              <a:rPr lang="en-US" sz="1300" dirty="0">
+              <a:rPr lang="en-US" sz="1700" dirty="0">
                 <a:solidFill>
                   <a:srgbClr val="1F2937"/>
                 </a:solidFill>
@@ -5888,7 +6332,7 @@
               </a:rPr>
               <a:t>- Solaris Assinaturas (fictícia)</a:t>
             </a:r>
-            <a:endParaRPr lang="en-US" sz="1300" dirty="0"/>
+            <a:endParaRPr lang="en-US" sz="1700" dirty="0"/>
           </a:p>
           <a:p>
             <a:pPr marL="342900" indent="-342900">
@@ -5899,7 +6343,7 @@
               <a:buChar char="●"/>
             </a:pPr>
             <a:r>
-              <a:rPr lang="en-US" sz="1300" dirty="0">
+              <a:rPr lang="en-US" sz="1700" dirty="0">
                 <a:solidFill>
                   <a:srgbClr val="1F2937"/>
                 </a:solidFill>
@@ -5909,7 +6353,7 @@
               </a:rPr>
               <a:t>- Maringá – PR</a:t>
             </a:r>
-            <a:endParaRPr lang="en-US" sz="1300" dirty="0"/>
+            <a:endParaRPr lang="en-US" sz="1700" dirty="0"/>
           </a:p>
           <a:p>
             <a:pPr marL="342900" indent="-342900">
@@ -5920,7 +6364,7 @@
               <a:buChar char="●"/>
             </a:pPr>
             <a:r>
-              <a:rPr lang="en-US" sz="1300" dirty="0">
+              <a:rPr lang="en-US" sz="1700" dirty="0">
                 <a:solidFill>
                   <a:srgbClr val="1F2937"/>
                 </a:solidFill>
@@ -5930,7 +6374,7 @@
               </a:rPr>
               <a:t>- Distribuidora da região: a do estado</a:t>
             </a:r>
-            <a:endParaRPr lang="en-US" sz="1300" dirty="0"/>
+            <a:endParaRPr lang="en-US" sz="1700" dirty="0"/>
           </a:p>
           <a:p>
             <a:pPr marL="342900" indent="-342900">
@@ -5941,7 +6385,7 @@
               <a:buChar char="●"/>
             </a:pPr>
             <a:r>
-              <a:rPr lang="en-US" sz="1300" dirty="0">
+              <a:rPr lang="en-US" sz="1700" dirty="0">
                 <a:solidFill>
                   <a:srgbClr val="1F2937"/>
                 </a:solidFill>
@@ -5951,7 +6395,7 @@
               </a:rPr>
               <a:t>- Empresa solar (integradora com 6 anos)</a:t>
             </a:r>
-            <a:endParaRPr lang="en-US" sz="1300" dirty="0"/>
+            <a:endParaRPr lang="en-US" sz="1700" dirty="0"/>
           </a:p>
           <a:p>
             <a:pPr marL="342900" indent="-342900">
@@ -5962,7 +6406,7 @@
               <a:buChar char="●"/>
             </a:pPr>
             <a:r>
-              <a:rPr lang="en-US" sz="1300" dirty="0">
+              <a:rPr lang="en-US" sz="1700" dirty="0">
                 <a:solidFill>
                   <a:srgbClr val="1F2937"/>
                 </a:solidFill>
@@ -5972,7 +6416,55 @@
               </a:rPr>
               <a:t>- 12 meses: 1 usina de 1 MW, 300 clientes</a:t>
             </a:r>
-            <a:endParaRPr lang="en-US" sz="1300" dirty="0"/>
+            <a:endParaRPr lang="en-US" sz="1700" dirty="0"/>
+          </a:p>
+        </p:txBody>
+      </p:sp>
+      <p:sp>
+        <p:nvSpPr>
+          <p:cNvPr id="25" name="Slide Number Placeholder 0"/>
+          <p:cNvSpPr>
+            <a:spLocks noGrp="1"/>
+          </p:cNvSpPr>
+          <p:nvPr>
+            <p:ph type="sldNum" sz="quarter" idx="4294967295"/>
+          </p:nvPr>
+        </p:nvSpPr>
+        <p:spPr>
+          <a:xfrm>
+            <a:off x="11292840" y="6556248"/>
+            <a:ext cx="548640" cy="256032"/>
+          </a:xfrm>
+          <a:prstGeom prst="rect">
+            <a:avLst/>
+          </a:prstGeom>
+          <a:extLst>
+            <a:ext uri="{C572A759-6A51-4108-AA02-DFA0A04FC94B}">
+              <ma14:wrappingTextBoxFlag xmlns:ma14="http://schemas.microsoft.com/office/mac/drawingml/2011/main" val="0"/>
+            </a:ext>
+          </a:extLst>
+        </p:spPr>
+        <p:txBody>
+          <a:bodyPr/>
+          <a:lstStyle>
+            <a:lvl1pPr>
+              <a:defRPr sz="900">
+                <a:solidFill>
+                  <a:srgbClr val="1B3A6B"/>
+                </a:solidFill>
+                <a:latin typeface="Arial"/>
+                <a:ea typeface="Arial"/>
+                <a:cs typeface="Arial"/>
+              </a:defRPr>
+            </a:lvl1pPr>
+          </a:lstStyle>
+          <a:p>
+            <a:pPr algn="r"/>
+            <a:fld id="{F7021451-1387-4CA6-816F-3879F97B5CBC}" type="slidenum">
+              <a:rPr b="1" lang="en-US"/>
+              <a:t>16</a:t>
+            </a:fld>
+            <a:endParaRPr lang="en-US"/>
           </a:p>
         </p:txBody>
       </p:sp>
@@ -6049,7 +6541,7 @@
         </p:blipFill>
         <p:spPr>
           <a:xfrm>
-            <a:off x="411480" y="6547104"/>
+            <a:off x="548640" y="6547104"/>
             <a:ext cx="274320" cy="274320"/>
           </a:xfrm>
           <a:prstGeom prst="rect">
@@ -6065,7 +6557,7 @@
         </p:nvSpPr>
         <p:spPr>
           <a:xfrm>
-            <a:off x="749808" y="6528816"/>
+            <a:off x="886968" y="6528816"/>
             <a:ext cx="6400800" cy="310896"/>
           </a:xfrm>
           <a:prstGeom prst="rect">
@@ -6105,7 +6597,7 @@
         <p:spPr>
           <a:xfrm>
             <a:off x="7132320" y="6528816"/>
-            <a:ext cx="4663440" cy="310896"/>
+            <a:ext cx="4023360" cy="310896"/>
           </a:xfrm>
           <a:prstGeom prst="rect">
             <a:avLst/>
@@ -6143,7 +6635,7 @@
         </p:nvSpPr>
         <p:spPr>
           <a:xfrm>
-            <a:off x="411480" y="384048"/>
+            <a:off x="548640" y="384048"/>
             <a:ext cx="82296" cy="658368"/>
           </a:xfrm>
           <a:prstGeom prst="rect">
@@ -6163,7 +6655,7 @@
         </p:nvSpPr>
         <p:spPr>
           <a:xfrm>
-            <a:off x="640080" y="292608"/>
+            <a:off x="777240" y="292608"/>
             <a:ext cx="10972800" cy="274320"/>
           </a:xfrm>
           <a:prstGeom prst="rect">
@@ -6202,8 +6694,8 @@
         </p:nvSpPr>
         <p:spPr>
           <a:xfrm>
-            <a:off x="640080" y="530352"/>
-            <a:ext cx="11155680" cy="566928"/>
+            <a:off x="777240" y="530352"/>
+            <a:ext cx="10881360" cy="566928"/>
           </a:xfrm>
           <a:prstGeom prst="rect">
             <a:avLst/>
@@ -6243,8 +6735,8 @@
         </p:nvSpPr>
         <p:spPr>
           <a:xfrm>
-            <a:off x="411480" y="1325880"/>
-            <a:ext cx="11384280" cy="4892040"/>
+            <a:off x="548640" y="1325880"/>
+            <a:ext cx="11091672" cy="4892040"/>
           </a:xfrm>
           <a:prstGeom prst="roundRect">
             <a:avLst>
@@ -6277,7 +6769,7 @@
         </p:nvSpPr>
         <p:spPr>
           <a:xfrm>
-            <a:off x="594360" y="1508760"/>
+            <a:off x="731520" y="1508760"/>
             <a:ext cx="457200" cy="457200"/>
           </a:xfrm>
           <a:prstGeom prst="ellipse">
@@ -6297,7 +6789,7 @@
         </p:nvSpPr>
         <p:spPr>
           <a:xfrm>
-            <a:off x="594360" y="1508760"/>
+            <a:off x="731520" y="1508760"/>
             <a:ext cx="457200" cy="457200"/>
           </a:xfrm>
           <a:prstGeom prst="rect">
@@ -6336,8 +6828,8 @@
         </p:nvSpPr>
         <p:spPr>
           <a:xfrm>
-            <a:off x="1188720" y="1435608"/>
-            <a:ext cx="10469880" cy="4672584"/>
+            <a:off x="1325880" y="1435608"/>
+            <a:ext cx="10177272" cy="4672584"/>
           </a:xfrm>
           <a:prstGeom prst="rect">
             <a:avLst/>
@@ -6366,6 +6858,54 @@
               <a:t>Cada módulo = uma peça da sua empresa</a:t>
             </a:r>
             <a:endParaRPr lang="en-US" sz="1800" dirty="0"/>
+          </a:p>
+        </p:txBody>
+      </p:sp>
+      <p:sp>
+        <p:nvSpPr>
+          <p:cNvPr id="25" name="Slide Number Placeholder 0"/>
+          <p:cNvSpPr>
+            <a:spLocks noGrp="1"/>
+          </p:cNvSpPr>
+          <p:nvPr>
+            <p:ph type="sldNum" sz="quarter" idx="4294967295"/>
+          </p:nvPr>
+        </p:nvSpPr>
+        <p:spPr>
+          <a:xfrm>
+            <a:off x="11292840" y="6556248"/>
+            <a:ext cx="548640" cy="256032"/>
+          </a:xfrm>
+          <a:prstGeom prst="rect">
+            <a:avLst/>
+          </a:prstGeom>
+          <a:extLst>
+            <a:ext uri="{C572A759-6A51-4108-AA02-DFA0A04FC94B}">
+              <ma14:wrappingTextBoxFlag xmlns:ma14="http://schemas.microsoft.com/office/mac/drawingml/2011/main" val="0"/>
+            </a:ext>
+          </a:extLst>
+        </p:spPr>
+        <p:txBody>
+          <a:bodyPr/>
+          <a:lstStyle>
+            <a:lvl1pPr>
+              <a:defRPr sz="900">
+                <a:solidFill>
+                  <a:srgbClr val="1B3A6B"/>
+                </a:solidFill>
+                <a:latin typeface="Arial"/>
+                <a:ea typeface="Arial"/>
+                <a:cs typeface="Arial"/>
+              </a:defRPr>
+            </a:lvl1pPr>
+          </a:lstStyle>
+          <a:p>
+            <a:pPr algn="r"/>
+            <a:fld id="{F7021451-1387-4CA6-816F-3879F97B5CBC}" type="slidenum">
+              <a:rPr b="1" lang="en-US"/>
+              <a:t>17</a:t>
+            </a:fld>
+            <a:endParaRPr lang="en-US"/>
           </a:p>
         </p:txBody>
       </p:sp>
@@ -6442,7 +6982,7 @@
         </p:blipFill>
         <p:spPr>
           <a:xfrm>
-            <a:off x="411480" y="6547104"/>
+            <a:off x="548640" y="6547104"/>
             <a:ext cx="274320" cy="274320"/>
           </a:xfrm>
           <a:prstGeom prst="rect">
@@ -6458,7 +6998,7 @@
         </p:nvSpPr>
         <p:spPr>
           <a:xfrm>
-            <a:off x="749808" y="6528816"/>
+            <a:off x="886968" y="6528816"/>
             <a:ext cx="6400800" cy="310896"/>
           </a:xfrm>
           <a:prstGeom prst="rect">
@@ -6498,7 +7038,7 @@
         <p:spPr>
           <a:xfrm>
             <a:off x="7132320" y="6528816"/>
-            <a:ext cx="4663440" cy="310896"/>
+            <a:ext cx="4023360" cy="310896"/>
           </a:xfrm>
           <a:prstGeom prst="rect">
             <a:avLst/>
@@ -6536,7 +7076,7 @@
         </p:nvSpPr>
         <p:spPr>
           <a:xfrm>
-            <a:off x="411480" y="384048"/>
+            <a:off x="548640" y="384048"/>
             <a:ext cx="82296" cy="658368"/>
           </a:xfrm>
           <a:prstGeom prst="rect">
@@ -6556,7 +7096,7 @@
         </p:nvSpPr>
         <p:spPr>
           <a:xfrm>
-            <a:off x="640080" y="292608"/>
+            <a:off x="777240" y="292608"/>
             <a:ext cx="10972800" cy="274320"/>
           </a:xfrm>
           <a:prstGeom prst="rect">
@@ -6595,8 +7135,8 @@
         </p:nvSpPr>
         <p:spPr>
           <a:xfrm>
-            <a:off x="640080" y="530352"/>
-            <a:ext cx="11155680" cy="566928"/>
+            <a:off x="777240" y="530352"/>
+            <a:ext cx="10881360" cy="566928"/>
           </a:xfrm>
           <a:prstGeom prst="rect">
             <a:avLst/>
@@ -6636,8 +7176,8 @@
         </p:nvSpPr>
         <p:spPr>
           <a:xfrm>
-            <a:off x="411480" y="1325880"/>
-            <a:ext cx="11384280" cy="4937760"/>
+            <a:off x="548640" y="1325880"/>
+            <a:ext cx="11091672" cy="4937760"/>
           </a:xfrm>
           <a:prstGeom prst="roundRect">
             <a:avLst>
@@ -6658,8 +7198,8 @@
         </p:nvSpPr>
         <p:spPr>
           <a:xfrm>
-            <a:off x="731520" y="1554480"/>
-            <a:ext cx="10744200" cy="4480560"/>
+            <a:off x="868680" y="1554480"/>
+            <a:ext cx="10451592" cy="4480560"/>
           </a:xfrm>
           <a:prstGeom prst="rect">
             <a:avLst/>
@@ -6703,6 +7243,54 @@
               <a:t>Ficha da minha empresa (modelo em 06-materiais-de-apoio.md): nome fictício da empresa, cidade/estado de atuação, distribuidora da região, perfil (começando do zero ou empresa solar), meta para 12 meses (ex.: 1 usina, 150 clientes). Postar na comunidade.</a:t>
             </a:r>
             <a:endParaRPr lang="en-US" sz="1300" dirty="0"/>
+          </a:p>
+        </p:txBody>
+      </p:sp>
+      <p:sp>
+        <p:nvSpPr>
+          <p:cNvPr id="25" name="Slide Number Placeholder 0"/>
+          <p:cNvSpPr>
+            <a:spLocks noGrp="1"/>
+          </p:cNvSpPr>
+          <p:nvPr>
+            <p:ph type="sldNum" sz="quarter" idx="4294967295"/>
+          </p:nvPr>
+        </p:nvSpPr>
+        <p:spPr>
+          <a:xfrm>
+            <a:off x="11292840" y="6556248"/>
+            <a:ext cx="548640" cy="256032"/>
+          </a:xfrm>
+          <a:prstGeom prst="rect">
+            <a:avLst/>
+          </a:prstGeom>
+          <a:extLst>
+            <a:ext uri="{C572A759-6A51-4108-AA02-DFA0A04FC94B}">
+              <ma14:wrappingTextBoxFlag xmlns:ma14="http://schemas.microsoft.com/office/mac/drawingml/2011/main" val="0"/>
+            </a:ext>
+          </a:extLst>
+        </p:spPr>
+        <p:txBody>
+          <a:bodyPr/>
+          <a:lstStyle>
+            <a:lvl1pPr>
+              <a:defRPr sz="900">
+                <a:solidFill>
+                  <a:srgbClr val="1B3A6B"/>
+                </a:solidFill>
+                <a:latin typeface="Arial"/>
+                <a:ea typeface="Arial"/>
+                <a:cs typeface="Arial"/>
+              </a:defRPr>
+            </a:lvl1pPr>
+          </a:lstStyle>
+          <a:p>
+            <a:pPr algn="r"/>
+            <a:fld id="{F7021451-1387-4CA6-816F-3879F97B5CBC}" type="slidenum">
+              <a:rPr b="1" lang="en-US"/>
+              <a:t>18</a:t>
+            </a:fld>
+            <a:endParaRPr lang="en-US"/>
           </a:p>
         </p:txBody>
       </p:sp>
@@ -6766,6 +7354,45 @@
         </p:nvSpPr>
         <p:spPr>
           <a:xfrm>
+            <a:off x="457200" y="548640"/>
+            <a:ext cx="3474720" cy="1737360"/>
+          </a:xfrm>
+          <a:prstGeom prst="rect">
+            <a:avLst/>
+          </a:prstGeom>
+          <a:noFill/>
+          <a:ln/>
+        </p:spPr>
+        <p:txBody>
+          <a:bodyPr wrap="square" rtlCol="0" anchor="ctr"/>
+          <a:lstStyle/>
+          <a:p>
+            <a:pPr indent="0" marL="0">
+              <a:buNone/>
+            </a:pPr>
+            <a:r>
+              <a:rPr lang="en-US" sz="11000" b="1" dirty="0">
+                <a:solidFill>
+                  <a:srgbClr val="11396F"/>
+                </a:solidFill>
+                <a:latin typeface="Arial" pitchFamily="34" charset="0"/>
+                <a:ea typeface="Arial" pitchFamily="34" charset="-122"/>
+                <a:cs typeface="Arial" pitchFamily="34" charset="-120"/>
+              </a:rPr>
+              <a:t>01</a:t>
+            </a:r>
+            <a:endParaRPr lang="en-US" sz="11000" dirty="0"/>
+          </a:p>
+        </p:txBody>
+      </p:sp>
+      <p:sp>
+        <p:nvSpPr>
+          <p:cNvPr id="4" name="Text 2"/>
+          <p:cNvSpPr/>
+          <p:nvPr/>
+        </p:nvSpPr>
+        <p:spPr>
+          <a:xfrm>
             <a:off x="548640" y="2194560"/>
             <a:ext cx="3291840" cy="548640"/>
           </a:xfrm>
@@ -6799,7 +7426,46 @@
       </p:sp>
       <p:sp>
         <p:nvSpPr>
-          <p:cNvPr id="4" name="Text 2"/>
+          <p:cNvPr id="5" name="Text 3"/>
+          <p:cNvSpPr/>
+          <p:nvPr/>
+        </p:nvSpPr>
+        <p:spPr>
+          <a:xfrm>
+            <a:off x="548640" y="3200400"/>
+            <a:ext cx="3383280" cy="457200"/>
+          </a:xfrm>
+          <a:prstGeom prst="rect">
+            <a:avLst/>
+          </a:prstGeom>
+          <a:noFill/>
+          <a:ln/>
+        </p:spPr>
+        <p:txBody>
+          <a:bodyPr wrap="square" rtlCol="0" anchor="ctr"/>
+          <a:lstStyle/>
+          <a:p>
+            <a:pPr indent="0" marL="0">
+              <a:buNone/>
+            </a:pPr>
+            <a:r>
+              <a:rPr lang="en-US" sz="1100" dirty="0">
+                <a:solidFill>
+                  <a:srgbClr val="C7D2E3"/>
+                </a:solidFill>
+                <a:latin typeface="Arial" pitchFamily="34" charset="0"/>
+                <a:ea typeface="Arial" pitchFamily="34" charset="-122"/>
+                <a:cs typeface="Arial" pitchFamily="34" charset="-120"/>
+              </a:rPr>
+              <a:t>M0 · Etapa 1 · Fundamentos</a:t>
+            </a:r>
+            <a:endParaRPr lang="en-US" sz="1100" dirty="0"/>
+          </a:p>
+        </p:txBody>
+      </p:sp>
+      <p:sp>
+        <p:nvSpPr>
+          <p:cNvPr id="6" name="Text 4"/>
           <p:cNvSpPr/>
           <p:nvPr/>
         </p:nvSpPr>
@@ -6838,7 +7504,7 @@
       </p:sp>
       <p:pic>
         <p:nvPicPr>
-          <p:cNvPr id="5" name="Image 0" descr="/www/wwwroot/rexar/gdsolar/docs/curso/slides/assets/logo-gdsolar.png">    </p:cNvPr>
+          <p:cNvPr id="7" name="Image 0" descr="/www/wwwroot/rexar/gdsolar/docs/curso/slides/assets/logo-gdsolar.png">    </p:cNvPr>
           <p:cNvPicPr>
             <a:picLocks noChangeAspect="1"/>
           </p:cNvPicPr>
@@ -6862,7 +7528,7 @@
       </p:pic>
       <p:sp>
         <p:nvSpPr>
-          <p:cNvPr id="6" name="Text 3"/>
+          <p:cNvPr id="8" name="Text 5"/>
           <p:cNvSpPr/>
           <p:nvPr/>
         </p:nvSpPr>
@@ -6903,7 +7569,7 @@
       </p:sp>
       <p:sp>
         <p:nvSpPr>
-          <p:cNvPr id="7" name="Text 4"/>
+          <p:cNvPr id="9" name="Text 6"/>
           <p:cNvSpPr/>
           <p:nvPr/>
         </p:nvSpPr>
@@ -6944,7 +7610,7 @@
       </p:sp>
       <p:sp>
         <p:nvSpPr>
-          <p:cNvPr id="8" name="Text 5"/>
+          <p:cNvPr id="10" name="Text 7"/>
           <p:cNvSpPr/>
           <p:nvPr/>
         </p:nvSpPr>
@@ -7123,7 +7789,7 @@
         </p:blipFill>
         <p:spPr>
           <a:xfrm>
-            <a:off x="411480" y="6547104"/>
+            <a:off x="548640" y="6547104"/>
             <a:ext cx="274320" cy="274320"/>
           </a:xfrm>
           <a:prstGeom prst="rect">
@@ -7139,7 +7805,7 @@
         </p:nvSpPr>
         <p:spPr>
           <a:xfrm>
-            <a:off x="749808" y="6528816"/>
+            <a:off x="886968" y="6528816"/>
             <a:ext cx="6400800" cy="310896"/>
           </a:xfrm>
           <a:prstGeom prst="rect">
@@ -7179,7 +7845,7 @@
         <p:spPr>
           <a:xfrm>
             <a:off x="7132320" y="6528816"/>
-            <a:ext cx="4663440" cy="310896"/>
+            <a:ext cx="4023360" cy="310896"/>
           </a:xfrm>
           <a:prstGeom prst="rect">
             <a:avLst/>
@@ -7217,7 +7883,7 @@
         </p:nvSpPr>
         <p:spPr>
           <a:xfrm>
-            <a:off x="411480" y="384048"/>
+            <a:off x="548640" y="384048"/>
             <a:ext cx="82296" cy="658368"/>
           </a:xfrm>
           <a:prstGeom prst="rect">
@@ -7237,7 +7903,7 @@
         </p:nvSpPr>
         <p:spPr>
           <a:xfrm>
-            <a:off x="640080" y="292608"/>
+            <a:off x="777240" y="292608"/>
             <a:ext cx="10972800" cy="274320"/>
           </a:xfrm>
           <a:prstGeom prst="rect">
@@ -7276,8 +7942,8 @@
         </p:nvSpPr>
         <p:spPr>
           <a:xfrm>
-            <a:off x="640080" y="530352"/>
-            <a:ext cx="11155680" cy="566928"/>
+            <a:off x="777240" y="530352"/>
+            <a:ext cx="10881360" cy="566928"/>
           </a:xfrm>
           <a:prstGeom prst="rect">
             <a:avLst/>
@@ -7317,8 +7983,8 @@
         </p:nvSpPr>
         <p:spPr>
           <a:xfrm>
-            <a:off x="411480" y="2651760"/>
-            <a:ext cx="2944368" cy="1463040"/>
+            <a:off x="548640" y="2651760"/>
+            <a:ext cx="2852928" cy="1463040"/>
           </a:xfrm>
           <a:prstGeom prst="chevron">
             <a:avLst/>
@@ -7342,8 +8008,8 @@
         </p:nvSpPr>
         <p:spPr>
           <a:xfrm>
-            <a:off x="731520" y="2651760"/>
-            <a:ext cx="2423160" cy="1463040"/>
+            <a:off x="868680" y="2651760"/>
+            <a:ext cx="2331720" cy="1463040"/>
           </a:xfrm>
           <a:prstGeom prst="rect">
             <a:avLst/>
@@ -7383,8 +8049,8 @@
         </p:nvSpPr>
         <p:spPr>
           <a:xfrm>
-            <a:off x="3246120" y="2651760"/>
-            <a:ext cx="2944368" cy="1463040"/>
+            <a:off x="3291840" y="2651760"/>
+            <a:ext cx="2852928" cy="1463040"/>
           </a:xfrm>
           <a:prstGeom prst="chevron">
             <a:avLst/>
@@ -7408,8 +8074,8 @@
         </p:nvSpPr>
         <p:spPr>
           <a:xfrm>
-            <a:off x="3566160" y="2651760"/>
-            <a:ext cx="2423160" cy="1463040"/>
+            <a:off x="3611880" y="2651760"/>
+            <a:ext cx="2331720" cy="1463040"/>
           </a:xfrm>
           <a:prstGeom prst="rect">
             <a:avLst/>
@@ -7449,8 +8115,8 @@
         </p:nvSpPr>
         <p:spPr>
           <a:xfrm>
-            <a:off x="6080760" y="2651760"/>
-            <a:ext cx="2944368" cy="1463040"/>
+            <a:off x="6035040" y="2651760"/>
+            <a:ext cx="2852928" cy="1463040"/>
           </a:xfrm>
           <a:prstGeom prst="chevron">
             <a:avLst/>
@@ -7474,8 +8140,8 @@
         </p:nvSpPr>
         <p:spPr>
           <a:xfrm>
-            <a:off x="6400800" y="2651760"/>
-            <a:ext cx="2423160" cy="1463040"/>
+            <a:off x="6355080" y="2651760"/>
+            <a:ext cx="2331720" cy="1463040"/>
           </a:xfrm>
           <a:prstGeom prst="rect">
             <a:avLst/>
@@ -7515,8 +8181,8 @@
         </p:nvSpPr>
         <p:spPr>
           <a:xfrm>
-            <a:off x="8915400" y="2651760"/>
-            <a:ext cx="2944368" cy="1463040"/>
+            <a:off x="8778240" y="2651760"/>
+            <a:ext cx="2852928" cy="1463040"/>
           </a:xfrm>
           <a:prstGeom prst="chevron">
             <a:avLst/>
@@ -7540,8 +8206,8 @@
         </p:nvSpPr>
         <p:spPr>
           <a:xfrm>
-            <a:off x="9235440" y="2651760"/>
-            <a:ext cx="2423160" cy="1463040"/>
+            <a:off x="9098280" y="2651760"/>
+            <a:ext cx="2331720" cy="1463040"/>
           </a:xfrm>
           <a:prstGeom prst="rect">
             <a:avLst/>
@@ -7570,6 +8236,54 @@
               <a:t>sua empresa organiza e cobra</a:t>
             </a:r>
             <a:endParaRPr lang="en-US" sz="1500" dirty="0"/>
+          </a:p>
+        </p:txBody>
+      </p:sp>
+      <p:sp>
+        <p:nvSpPr>
+          <p:cNvPr id="25" name="Slide Number Placeholder 0"/>
+          <p:cNvSpPr>
+            <a:spLocks noGrp="1"/>
+          </p:cNvSpPr>
+          <p:nvPr>
+            <p:ph type="sldNum" sz="quarter" idx="4294967295"/>
+          </p:nvPr>
+        </p:nvSpPr>
+        <p:spPr>
+          <a:xfrm>
+            <a:off x="11292840" y="6556248"/>
+            <a:ext cx="548640" cy="256032"/>
+          </a:xfrm>
+          <a:prstGeom prst="rect">
+            <a:avLst/>
+          </a:prstGeom>
+          <a:extLst>
+            <a:ext uri="{C572A759-6A51-4108-AA02-DFA0A04FC94B}">
+              <ma14:wrappingTextBoxFlag xmlns:ma14="http://schemas.microsoft.com/office/mac/drawingml/2011/main" val="0"/>
+            </a:ext>
+          </a:extLst>
+        </p:spPr>
+        <p:txBody>
+          <a:bodyPr/>
+          <a:lstStyle>
+            <a:lvl1pPr>
+              <a:defRPr sz="900">
+                <a:solidFill>
+                  <a:srgbClr val="1B3A6B"/>
+                </a:solidFill>
+                <a:latin typeface="Arial"/>
+                <a:ea typeface="Arial"/>
+                <a:cs typeface="Arial"/>
+              </a:defRPr>
+            </a:lvl1pPr>
+          </a:lstStyle>
+          <a:p>
+            <a:pPr algn="r"/>
+            <a:fld id="{F7021451-1387-4CA6-816F-3879F97B5CBC}" type="slidenum">
+              <a:rPr b="1" lang="en-US"/>
+              <a:t>3</a:t>
+            </a:fld>
+            <a:endParaRPr lang="en-US"/>
           </a:p>
         </p:txBody>
       </p:sp>
@@ -7646,7 +8360,7 @@
         </p:blipFill>
         <p:spPr>
           <a:xfrm>
-            <a:off x="411480" y="6547104"/>
+            <a:off x="548640" y="6547104"/>
             <a:ext cx="274320" cy="274320"/>
           </a:xfrm>
           <a:prstGeom prst="rect">
@@ -7662,7 +8376,7 @@
         </p:nvSpPr>
         <p:spPr>
           <a:xfrm>
-            <a:off x="749808" y="6528816"/>
+            <a:off x="886968" y="6528816"/>
             <a:ext cx="6400800" cy="310896"/>
           </a:xfrm>
           <a:prstGeom prst="rect">
@@ -7702,7 +8416,7 @@
         <p:spPr>
           <a:xfrm>
             <a:off x="7132320" y="6528816"/>
-            <a:ext cx="4663440" cy="310896"/>
+            <a:ext cx="4023360" cy="310896"/>
           </a:xfrm>
           <a:prstGeom prst="rect">
             <a:avLst/>
@@ -7740,7 +8454,7 @@
         </p:nvSpPr>
         <p:spPr>
           <a:xfrm>
-            <a:off x="411480" y="384048"/>
+            <a:off x="548640" y="384048"/>
             <a:ext cx="82296" cy="658368"/>
           </a:xfrm>
           <a:prstGeom prst="rect">
@@ -7760,7 +8474,7 @@
         </p:nvSpPr>
         <p:spPr>
           <a:xfrm>
-            <a:off x="640080" y="292608"/>
+            <a:off x="777240" y="292608"/>
             <a:ext cx="10972800" cy="274320"/>
           </a:xfrm>
           <a:prstGeom prst="rect">
@@ -7799,8 +8513,8 @@
         </p:nvSpPr>
         <p:spPr>
           <a:xfrm>
-            <a:off x="640080" y="530352"/>
-            <a:ext cx="11155680" cy="566928"/>
+            <a:off x="777240" y="530352"/>
+            <a:ext cx="10881360" cy="566928"/>
           </a:xfrm>
           <a:prstGeom prst="rect">
             <a:avLst/>
@@ -7840,12 +8554,12 @@
         </p:nvSpPr>
         <p:spPr>
           <a:xfrm>
-            <a:off x="411480" y="1325880"/>
-            <a:ext cx="3642360" cy="4892040"/>
+            <a:off x="548640" y="1325880"/>
+            <a:ext cx="3544824" cy="4892040"/>
           </a:xfrm>
           <a:prstGeom prst="roundRect">
             <a:avLst>
-              <a:gd name="adj" fmla="val 2008"/>
+              <a:gd name="adj" fmla="val 2064"/>
             </a:avLst>
           </a:prstGeom>
           <a:solidFill>
@@ -7874,7 +8588,7 @@
         </p:nvSpPr>
         <p:spPr>
           <a:xfrm>
-            <a:off x="594360" y="1508760"/>
+            <a:off x="731520" y="1508760"/>
             <a:ext cx="457200" cy="457200"/>
           </a:xfrm>
           <a:prstGeom prst="ellipse">
@@ -7894,7 +8608,7 @@
         </p:nvSpPr>
         <p:spPr>
           <a:xfrm>
-            <a:off x="594360" y="1508760"/>
+            <a:off x="731520" y="1508760"/>
             <a:ext cx="457200" cy="457200"/>
           </a:xfrm>
           <a:prstGeom prst="rect">
@@ -7933,8 +8647,8 @@
         </p:nvSpPr>
         <p:spPr>
           <a:xfrm>
-            <a:off x="1188720" y="1435608"/>
-            <a:ext cx="2727960" cy="4672584"/>
+            <a:off x="1325880" y="1435608"/>
+            <a:ext cx="2630424" cy="4672584"/>
           </a:xfrm>
           <a:prstGeom prst="rect">
             <a:avLst/>
@@ -7974,12 +8688,12 @@
         </p:nvSpPr>
         <p:spPr>
           <a:xfrm>
-            <a:off x="4282440" y="1325880"/>
-            <a:ext cx="3642360" cy="4892040"/>
+            <a:off x="4322064" y="1325880"/>
+            <a:ext cx="3544824" cy="4892040"/>
           </a:xfrm>
           <a:prstGeom prst="roundRect">
             <a:avLst>
-              <a:gd name="adj" fmla="val 2008"/>
+              <a:gd name="adj" fmla="val 2064"/>
             </a:avLst>
           </a:prstGeom>
           <a:solidFill>
@@ -8008,7 +8722,7 @@
         </p:nvSpPr>
         <p:spPr>
           <a:xfrm>
-            <a:off x="4465320" y="1508760"/>
+            <a:off x="4504944" y="1508760"/>
             <a:ext cx="457200" cy="457200"/>
           </a:xfrm>
           <a:prstGeom prst="ellipse">
@@ -8028,7 +8742,7 @@
         </p:nvSpPr>
         <p:spPr>
           <a:xfrm>
-            <a:off x="4465320" y="1508760"/>
+            <a:off x="4504944" y="1508760"/>
             <a:ext cx="457200" cy="457200"/>
           </a:xfrm>
           <a:prstGeom prst="rect">
@@ -8067,8 +8781,8 @@
         </p:nvSpPr>
         <p:spPr>
           <a:xfrm>
-            <a:off x="5059680" y="1435608"/>
-            <a:ext cx="2727960" cy="4672584"/>
+            <a:off x="5099304" y="1435608"/>
+            <a:ext cx="2630424" cy="4672584"/>
           </a:xfrm>
           <a:prstGeom prst="rect">
             <a:avLst/>
@@ -8108,12 +8822,12 @@
         </p:nvSpPr>
         <p:spPr>
           <a:xfrm>
-            <a:off x="8153400" y="1325880"/>
-            <a:ext cx="3642360" cy="4892040"/>
+            <a:off x="8095488" y="1325880"/>
+            <a:ext cx="3544824" cy="4892040"/>
           </a:xfrm>
           <a:prstGeom prst="roundRect">
             <a:avLst>
-              <a:gd name="adj" fmla="val 2008"/>
+              <a:gd name="adj" fmla="val 2064"/>
             </a:avLst>
           </a:prstGeom>
           <a:solidFill>
@@ -8142,7 +8856,7 @@
         </p:nvSpPr>
         <p:spPr>
           <a:xfrm>
-            <a:off x="8336280" y="1508760"/>
+            <a:off x="8278368" y="1508760"/>
             <a:ext cx="457200" cy="457200"/>
           </a:xfrm>
           <a:prstGeom prst="ellipse">
@@ -8162,7 +8876,7 @@
         </p:nvSpPr>
         <p:spPr>
           <a:xfrm>
-            <a:off x="8336280" y="1508760"/>
+            <a:off x="8278368" y="1508760"/>
             <a:ext cx="457200" cy="457200"/>
           </a:xfrm>
           <a:prstGeom prst="rect">
@@ -8201,8 +8915,8 @@
         </p:nvSpPr>
         <p:spPr>
           <a:xfrm>
-            <a:off x="8930640" y="1435608"/>
-            <a:ext cx="2727960" cy="4672584"/>
+            <a:off x="8872728" y="1435608"/>
+            <a:ext cx="2630424" cy="4672584"/>
           </a:xfrm>
           <a:prstGeom prst="rect">
             <a:avLst/>
@@ -8231,6 +8945,54 @@
               <a:t>Todos ganham</a:t>
             </a:r>
             <a:endParaRPr lang="en-US" sz="1800" dirty="0"/>
+          </a:p>
+        </p:txBody>
+      </p:sp>
+      <p:sp>
+        <p:nvSpPr>
+          <p:cNvPr id="25" name="Slide Number Placeholder 0"/>
+          <p:cNvSpPr>
+            <a:spLocks noGrp="1"/>
+          </p:cNvSpPr>
+          <p:nvPr>
+            <p:ph type="sldNum" sz="quarter" idx="4294967295"/>
+          </p:nvPr>
+        </p:nvSpPr>
+        <p:spPr>
+          <a:xfrm>
+            <a:off x="11292840" y="6556248"/>
+            <a:ext cx="548640" cy="256032"/>
+          </a:xfrm>
+          <a:prstGeom prst="rect">
+            <a:avLst/>
+          </a:prstGeom>
+          <a:extLst>
+            <a:ext uri="{C572A759-6A51-4108-AA02-DFA0A04FC94B}">
+              <ma14:wrappingTextBoxFlag xmlns:ma14="http://schemas.microsoft.com/office/mac/drawingml/2011/main" val="0"/>
+            </a:ext>
+          </a:extLst>
+        </p:spPr>
+        <p:txBody>
+          <a:bodyPr/>
+          <a:lstStyle>
+            <a:lvl1pPr>
+              <a:defRPr sz="900">
+                <a:solidFill>
+                  <a:srgbClr val="1B3A6B"/>
+                </a:solidFill>
+                <a:latin typeface="Arial"/>
+                <a:ea typeface="Arial"/>
+                <a:cs typeface="Arial"/>
+              </a:defRPr>
+            </a:lvl1pPr>
+          </a:lstStyle>
+          <a:p>
+            <a:pPr algn="r"/>
+            <a:fld id="{F7021451-1387-4CA6-816F-3879F97B5CBC}" type="slidenum">
+              <a:rPr b="1" lang="en-US"/>
+              <a:t>4</a:t>
+            </a:fld>
+            <a:endParaRPr lang="en-US"/>
           </a:p>
         </p:txBody>
       </p:sp>
@@ -8307,7 +9069,7 @@
         </p:blipFill>
         <p:spPr>
           <a:xfrm>
-            <a:off x="411480" y="6547104"/>
+            <a:off x="548640" y="6547104"/>
             <a:ext cx="274320" cy="274320"/>
           </a:xfrm>
           <a:prstGeom prst="rect">
@@ -8323,7 +9085,7 @@
         </p:nvSpPr>
         <p:spPr>
           <a:xfrm>
-            <a:off x="749808" y="6528816"/>
+            <a:off x="886968" y="6528816"/>
             <a:ext cx="6400800" cy="310896"/>
           </a:xfrm>
           <a:prstGeom prst="rect">
@@ -8363,7 +9125,7 @@
         <p:spPr>
           <a:xfrm>
             <a:off x="7132320" y="6528816"/>
-            <a:ext cx="4663440" cy="310896"/>
+            <a:ext cx="4023360" cy="310896"/>
           </a:xfrm>
           <a:prstGeom prst="rect">
             <a:avLst/>
@@ -8401,7 +9163,7 @@
         </p:nvSpPr>
         <p:spPr>
           <a:xfrm>
-            <a:off x="411480" y="384048"/>
+            <a:off x="548640" y="384048"/>
             <a:ext cx="82296" cy="658368"/>
           </a:xfrm>
           <a:prstGeom prst="rect">
@@ -8421,7 +9183,7 @@
         </p:nvSpPr>
         <p:spPr>
           <a:xfrm>
-            <a:off x="640080" y="292608"/>
+            <a:off x="777240" y="292608"/>
             <a:ext cx="10972800" cy="274320"/>
           </a:xfrm>
           <a:prstGeom prst="rect">
@@ -8460,8 +9222,8 @@
         </p:nvSpPr>
         <p:spPr>
           <a:xfrm>
-            <a:off x="640080" y="530352"/>
-            <a:ext cx="11155680" cy="566928"/>
+            <a:off x="777240" y="530352"/>
+            <a:ext cx="10881360" cy="566928"/>
           </a:xfrm>
           <a:prstGeom prst="rect">
             <a:avLst/>
@@ -8502,7 +9264,7 @@
         <p:spPr>
           <a:xfrm>
             <a:off x="548640" y="1325880"/>
-            <a:ext cx="11155680" cy="4937760"/>
+            <a:ext cx="5486400" cy="4937760"/>
           </a:xfrm>
           <a:prstGeom prst="rect">
             <a:avLst/>
@@ -8523,7 +9285,7 @@
               <a:buNone/>
             </a:pPr>
             <a:r>
-              <a:rPr lang="en-US" sz="1400" dirty="0">
+              <a:rPr lang="en-US" sz="1800" dirty="0">
                 <a:solidFill>
                   <a:srgbClr val="1F2937"/>
                 </a:solidFill>
@@ -8533,7 +9295,7 @@
               </a:rPr>
               <a:t>1. Ler qualquer conta de luz com energia compensada</a:t>
             </a:r>
-            <a:endParaRPr lang="en-US" sz="1400" dirty="0"/>
+            <a:endParaRPr lang="en-US" sz="1800" dirty="0"/>
           </a:p>
           <a:p>
             <a:pPr indent="0" marL="0">
@@ -8543,7 +9305,7 @@
               <a:buNone/>
             </a:pPr>
             <a:r>
-              <a:rPr lang="en-US" sz="1400" dirty="0">
+              <a:rPr lang="en-US" sz="1800" dirty="0">
                 <a:solidFill>
                   <a:srgbClr val="1F2937"/>
                 </a:solidFill>
@@ -8553,7 +9315,7 @@
               </a:rPr>
               <a:t>2. Fazer a conta do kWh: cliente, produtor e sua empresa</a:t>
             </a:r>
-            <a:endParaRPr lang="en-US" sz="1400" dirty="0"/>
+            <a:endParaRPr lang="en-US" sz="1800" dirty="0"/>
           </a:p>
           <a:p>
             <a:pPr indent="0" marL="0">
@@ -8563,7 +9325,7 @@
               <a:buNone/>
             </a:pPr>
             <a:r>
-              <a:rPr lang="en-US" sz="1400" dirty="0">
+              <a:rPr lang="en-US" sz="1800" dirty="0">
                 <a:solidFill>
                   <a:srgbClr val="1F2937"/>
                 </a:solidFill>
@@ -8573,7 +9335,7 @@
               </a:rPr>
               <a:t>3. Montar propostas para clientes e donos de usina</a:t>
             </a:r>
-            <a:endParaRPr lang="en-US" sz="1400" dirty="0"/>
+            <a:endParaRPr lang="en-US" sz="1800" dirty="0"/>
           </a:p>
           <a:p>
             <a:pPr indent="0" marL="0">
@@ -8583,7 +9345,7 @@
               <a:buNone/>
             </a:pPr>
             <a:r>
-              <a:rPr lang="en-US" sz="1400" dirty="0">
+              <a:rPr lang="en-US" sz="1800" dirty="0">
                 <a:solidFill>
                   <a:srgbClr val="1F2937"/>
                 </a:solidFill>
@@ -8593,8 +9355,32 @@
               </a:rPr>
               <a:t>4. Distribuir a energia da usina sem vender o que não existe</a:t>
             </a:r>
-            <a:endParaRPr lang="en-US" sz="1400" dirty="0"/>
-          </a:p>
+            <a:endParaRPr lang="en-US" sz="1800" dirty="0"/>
+          </a:p>
+        </p:txBody>
+      </p:sp>
+      <p:sp>
+        <p:nvSpPr>
+          <p:cNvPr id="10" name="Text 7"/>
+          <p:cNvSpPr/>
+          <p:nvPr/>
+        </p:nvSpPr>
+        <p:spPr>
+          <a:xfrm>
+            <a:off x="6263640" y="1325880"/>
+            <a:ext cx="5486400" cy="4937760"/>
+          </a:xfrm>
+          <a:prstGeom prst="rect">
+            <a:avLst/>
+          </a:prstGeom>
+          <a:noFill/>
+          <a:ln/>
+        </p:spPr>
+        <p:txBody>
+          <a:bodyPr wrap="square" rtlCol="0" anchor="t">
+            <a:normAutofit/>
+          </a:bodyPr>
+          <a:lstStyle/>
           <a:p>
             <a:pPr indent="0" marL="0">
               <a:spcAft>
@@ -8603,7 +9389,7 @@
               <a:buNone/>
             </a:pPr>
             <a:r>
-              <a:rPr lang="en-US" sz="1400" dirty="0">
+              <a:rPr lang="en-US" sz="1800" dirty="0">
                 <a:solidFill>
                   <a:srgbClr val="1F2937"/>
                 </a:solidFill>
@@ -8613,7 +9399,7 @@
               </a:rPr>
               <a:t>5. Fechar o mês: faturas, cobranças, Pix e boleto</a:t>
             </a:r>
-            <a:endParaRPr lang="en-US" sz="1400" dirty="0"/>
+            <a:endParaRPr lang="en-US" sz="1800" dirty="0"/>
           </a:p>
           <a:p>
             <a:pPr indent="0" marL="0">
@@ -8623,7 +9409,7 @@
               <a:buNone/>
             </a:pPr>
             <a:r>
-              <a:rPr lang="en-US" sz="1400" dirty="0">
+              <a:rPr lang="en-US" sz="1800" dirty="0">
                 <a:solidFill>
                   <a:srgbClr val="1F2937"/>
                 </a:solidFill>
@@ -8633,7 +9419,7 @@
               </a:rPr>
               <a:t>6. Medir o negócio com indicadores e relatórios</a:t>
             </a:r>
-            <a:endParaRPr lang="en-US" sz="1400" dirty="0"/>
+            <a:endParaRPr lang="en-US" sz="1800" dirty="0"/>
           </a:p>
           <a:p>
             <a:pPr indent="0" marL="0">
@@ -8643,7 +9429,7 @@
               <a:buNone/>
             </a:pPr>
             <a:r>
-              <a:rPr lang="en-US" sz="1400" dirty="0">
+              <a:rPr lang="en-US" sz="1800" dirty="0">
                 <a:solidFill>
                   <a:srgbClr val="1F2937"/>
                 </a:solidFill>
@@ -8653,7 +9439,55 @@
               </a:rPr>
               <a:t>7. Montar o plano da sua empresa</a:t>
             </a:r>
-            <a:endParaRPr lang="en-US" sz="1400" dirty="0"/>
+            <a:endParaRPr lang="en-US" sz="1800" dirty="0"/>
+          </a:p>
+        </p:txBody>
+      </p:sp>
+      <p:sp>
+        <p:nvSpPr>
+          <p:cNvPr id="25" name="Slide Number Placeholder 0"/>
+          <p:cNvSpPr>
+            <a:spLocks noGrp="1"/>
+          </p:cNvSpPr>
+          <p:nvPr>
+            <p:ph type="sldNum" sz="quarter" idx="4294967295"/>
+          </p:nvPr>
+        </p:nvSpPr>
+        <p:spPr>
+          <a:xfrm>
+            <a:off x="11292840" y="6556248"/>
+            <a:ext cx="548640" cy="256032"/>
+          </a:xfrm>
+          <a:prstGeom prst="rect">
+            <a:avLst/>
+          </a:prstGeom>
+          <a:extLst>
+            <a:ext uri="{C572A759-6A51-4108-AA02-DFA0A04FC94B}">
+              <ma14:wrappingTextBoxFlag xmlns:ma14="http://schemas.microsoft.com/office/mac/drawingml/2011/main" val="0"/>
+            </a:ext>
+          </a:extLst>
+        </p:spPr>
+        <p:txBody>
+          <a:bodyPr/>
+          <a:lstStyle>
+            <a:lvl1pPr>
+              <a:defRPr sz="900">
+                <a:solidFill>
+                  <a:srgbClr val="1B3A6B"/>
+                </a:solidFill>
+                <a:latin typeface="Arial"/>
+                <a:ea typeface="Arial"/>
+                <a:cs typeface="Arial"/>
+              </a:defRPr>
+            </a:lvl1pPr>
+          </a:lstStyle>
+          <a:p>
+            <a:pPr algn="r"/>
+            <a:fld id="{F7021451-1387-4CA6-816F-3879F97B5CBC}" type="slidenum">
+              <a:rPr b="1" lang="en-US"/>
+              <a:t>5</a:t>
+            </a:fld>
+            <a:endParaRPr lang="en-US"/>
           </a:p>
         </p:txBody>
       </p:sp>
@@ -8730,7 +9564,7 @@
         </p:blipFill>
         <p:spPr>
           <a:xfrm>
-            <a:off x="411480" y="6547104"/>
+            <a:off x="548640" y="6547104"/>
             <a:ext cx="274320" cy="274320"/>
           </a:xfrm>
           <a:prstGeom prst="rect">
@@ -8746,7 +9580,7 @@
         </p:nvSpPr>
         <p:spPr>
           <a:xfrm>
-            <a:off x="749808" y="6528816"/>
+            <a:off x="886968" y="6528816"/>
             <a:ext cx="6400800" cy="310896"/>
           </a:xfrm>
           <a:prstGeom prst="rect">
@@ -8786,7 +9620,7 @@
         <p:spPr>
           <a:xfrm>
             <a:off x="7132320" y="6528816"/>
-            <a:ext cx="4663440" cy="310896"/>
+            <a:ext cx="4023360" cy="310896"/>
           </a:xfrm>
           <a:prstGeom prst="rect">
             <a:avLst/>
@@ -8824,7 +9658,7 @@
         </p:nvSpPr>
         <p:spPr>
           <a:xfrm>
-            <a:off x="411480" y="384048"/>
+            <a:off x="548640" y="384048"/>
             <a:ext cx="82296" cy="658368"/>
           </a:xfrm>
           <a:prstGeom prst="rect">
@@ -8844,7 +9678,7 @@
         </p:nvSpPr>
         <p:spPr>
           <a:xfrm>
-            <a:off x="640080" y="292608"/>
+            <a:off x="777240" y="292608"/>
             <a:ext cx="10972800" cy="274320"/>
           </a:xfrm>
           <a:prstGeom prst="rect">
@@ -8883,8 +9717,8 @@
         </p:nvSpPr>
         <p:spPr>
           <a:xfrm>
-            <a:off x="640080" y="530352"/>
-            <a:ext cx="11155680" cy="566928"/>
+            <a:off x="777240" y="530352"/>
+            <a:ext cx="10881360" cy="566928"/>
           </a:xfrm>
           <a:prstGeom prst="rect">
             <a:avLst/>
@@ -8924,8 +9758,8 @@
         </p:nvSpPr>
         <p:spPr>
           <a:xfrm>
-            <a:off x="411480" y="1325880"/>
-            <a:ext cx="11384280" cy="4937760"/>
+            <a:off x="548640" y="1325880"/>
+            <a:ext cx="11091672" cy="4937760"/>
           </a:xfrm>
           <a:prstGeom prst="roundRect">
             <a:avLst>
@@ -8951,7 +9785,7 @@
         </p:nvSpPr>
         <p:spPr>
           <a:xfrm>
-            <a:off x="594360" y="1508760"/>
+            <a:off x="731520" y="1508760"/>
             <a:ext cx="822960" cy="384048"/>
           </a:xfrm>
           <a:prstGeom prst="roundRect">
@@ -8973,7 +9807,7 @@
         </p:nvSpPr>
         <p:spPr>
           <a:xfrm>
-            <a:off x="594360" y="1508760"/>
+            <a:off x="731520" y="1508760"/>
             <a:ext cx="822960" cy="384048"/>
           </a:xfrm>
           <a:prstGeom prst="rect">
@@ -9012,8 +9846,8 @@
         </p:nvSpPr>
         <p:spPr>
           <a:xfrm>
-            <a:off x="1508760" y="1463040"/>
-            <a:ext cx="10149840" cy="502920"/>
+            <a:off x="1645920" y="1463040"/>
+            <a:ext cx="9857232" cy="502920"/>
           </a:xfrm>
           <a:prstGeom prst="rect">
             <a:avLst/>
@@ -9053,8 +9887,8 @@
         </p:nvSpPr>
         <p:spPr>
           <a:xfrm>
-            <a:off x="640080" y="2057400"/>
-            <a:ext cx="10927080" cy="4069080"/>
+            <a:off x="777240" y="2057400"/>
+            <a:ext cx="10634472" cy="4069080"/>
           </a:xfrm>
           <a:prstGeom prst="rect">
             <a:avLst/>
@@ -9083,6 +9917,54 @@
               <a:t>Você vai praticar numa plataforma real</a:t>
             </a:r>
             <a:endParaRPr lang="en-US" sz="1500" dirty="0"/>
+          </a:p>
+        </p:txBody>
+      </p:sp>
+      <p:sp>
+        <p:nvSpPr>
+          <p:cNvPr id="25" name="Slide Number Placeholder 0"/>
+          <p:cNvSpPr>
+            <a:spLocks noGrp="1"/>
+          </p:cNvSpPr>
+          <p:nvPr>
+            <p:ph type="sldNum" sz="quarter" idx="4294967295"/>
+          </p:nvPr>
+        </p:nvSpPr>
+        <p:spPr>
+          <a:xfrm>
+            <a:off x="11292840" y="6556248"/>
+            <a:ext cx="548640" cy="256032"/>
+          </a:xfrm>
+          <a:prstGeom prst="rect">
+            <a:avLst/>
+          </a:prstGeom>
+          <a:extLst>
+            <a:ext uri="{C572A759-6A51-4108-AA02-DFA0A04FC94B}">
+              <ma14:wrappingTextBoxFlag xmlns:ma14="http://schemas.microsoft.com/office/mac/drawingml/2011/main" val="0"/>
+            </a:ext>
+          </a:extLst>
+        </p:spPr>
+        <p:txBody>
+          <a:bodyPr/>
+          <a:lstStyle>
+            <a:lvl1pPr>
+              <a:defRPr sz="900">
+                <a:solidFill>
+                  <a:srgbClr val="1B3A6B"/>
+                </a:solidFill>
+                <a:latin typeface="Arial"/>
+                <a:ea typeface="Arial"/>
+                <a:cs typeface="Arial"/>
+              </a:defRPr>
+            </a:lvl1pPr>
+          </a:lstStyle>
+          <a:p>
+            <a:pPr algn="r"/>
+            <a:fld id="{F7021451-1387-4CA6-816F-3879F97B5CBC}" type="slidenum">
+              <a:rPr b="1" lang="en-US"/>
+              <a:t>6</a:t>
+            </a:fld>
+            <a:endParaRPr lang="en-US"/>
           </a:p>
         </p:txBody>
       </p:sp>
@@ -9146,6 +10028,45 @@
         </p:nvSpPr>
         <p:spPr>
           <a:xfrm>
+            <a:off x="457200" y="548640"/>
+            <a:ext cx="3474720" cy="1737360"/>
+          </a:xfrm>
+          <a:prstGeom prst="rect">
+            <a:avLst/>
+          </a:prstGeom>
+          <a:noFill/>
+          <a:ln/>
+        </p:spPr>
+        <p:txBody>
+          <a:bodyPr wrap="square" rtlCol="0" anchor="ctr"/>
+          <a:lstStyle/>
+          <a:p>
+            <a:pPr indent="0" marL="0">
+              <a:buNone/>
+            </a:pPr>
+            <a:r>
+              <a:rPr lang="en-US" sz="11000" b="1" dirty="0">
+                <a:solidFill>
+                  <a:srgbClr val="11396F"/>
+                </a:solidFill>
+                <a:latin typeface="Arial" pitchFamily="34" charset="0"/>
+                <a:ea typeface="Arial" pitchFamily="34" charset="-122"/>
+                <a:cs typeface="Arial" pitchFamily="34" charset="-120"/>
+              </a:rPr>
+              <a:t>02</a:t>
+            </a:r>
+            <a:endParaRPr lang="en-US" sz="11000" dirty="0"/>
+          </a:p>
+        </p:txBody>
+      </p:sp>
+      <p:sp>
+        <p:nvSpPr>
+          <p:cNvPr id="4" name="Text 2"/>
+          <p:cNvSpPr/>
+          <p:nvPr/>
+        </p:nvSpPr>
+        <p:spPr>
+          <a:xfrm>
             <a:off x="548640" y="2194560"/>
             <a:ext cx="3291840" cy="548640"/>
           </a:xfrm>
@@ -9179,7 +10100,46 @@
       </p:sp>
       <p:sp>
         <p:nvSpPr>
-          <p:cNvPr id="4" name="Text 2"/>
+          <p:cNvPr id="5" name="Text 3"/>
+          <p:cNvSpPr/>
+          <p:nvPr/>
+        </p:nvSpPr>
+        <p:spPr>
+          <a:xfrm>
+            <a:off x="548640" y="3200400"/>
+            <a:ext cx="3383280" cy="457200"/>
+          </a:xfrm>
+          <a:prstGeom prst="rect">
+            <a:avLst/>
+          </a:prstGeom>
+          <a:noFill/>
+          <a:ln/>
+        </p:spPr>
+        <p:txBody>
+          <a:bodyPr wrap="square" rtlCol="0" anchor="ctr"/>
+          <a:lstStyle/>
+          <a:p>
+            <a:pPr indent="0" marL="0">
+              <a:buNone/>
+            </a:pPr>
+            <a:r>
+              <a:rPr lang="en-US" sz="1100" dirty="0">
+                <a:solidFill>
+                  <a:srgbClr val="C7D2E3"/>
+                </a:solidFill>
+                <a:latin typeface="Arial" pitchFamily="34" charset="0"/>
+                <a:ea typeface="Arial" pitchFamily="34" charset="-122"/>
+                <a:cs typeface="Arial" pitchFamily="34" charset="-120"/>
+              </a:rPr>
+              <a:t>M0 · Etapa 1 · Fundamentos</a:t>
+            </a:r>
+            <a:endParaRPr lang="en-US" sz="1100" dirty="0"/>
+          </a:p>
+        </p:txBody>
+      </p:sp>
+      <p:sp>
+        <p:nvSpPr>
+          <p:cNvPr id="6" name="Text 4"/>
           <p:cNvSpPr/>
           <p:nvPr/>
         </p:nvSpPr>
@@ -9218,7 +10178,7 @@
       </p:sp>
       <p:pic>
         <p:nvPicPr>
-          <p:cNvPr id="5" name="Image 0" descr="/www/wwwroot/rexar/gdsolar/docs/curso/slides/assets/logo-gdsolar.png">    </p:cNvPr>
+          <p:cNvPr id="7" name="Image 0" descr="/www/wwwroot/rexar/gdsolar/docs/curso/slides/assets/logo-gdsolar.png">    </p:cNvPr>
           <p:cNvPicPr>
             <a:picLocks noChangeAspect="1"/>
           </p:cNvPicPr>
@@ -9242,7 +10202,7 @@
       </p:pic>
       <p:sp>
         <p:nvSpPr>
-          <p:cNvPr id="6" name="Text 3"/>
+          <p:cNvPr id="8" name="Text 5"/>
           <p:cNvSpPr/>
           <p:nvPr/>
         </p:nvSpPr>
@@ -9283,7 +10243,7 @@
       </p:sp>
       <p:sp>
         <p:nvSpPr>
-          <p:cNvPr id="7" name="Text 4"/>
+          <p:cNvPr id="9" name="Text 6"/>
           <p:cNvSpPr/>
           <p:nvPr/>
         </p:nvSpPr>
@@ -9324,7 +10284,7 @@
       </p:sp>
       <p:sp>
         <p:nvSpPr>
-          <p:cNvPr id="8" name="Text 5"/>
+          <p:cNvPr id="10" name="Text 7"/>
           <p:cNvSpPr/>
           <p:nvPr/>
         </p:nvSpPr>
@@ -9503,7 +10463,7 @@
         </p:blipFill>
         <p:spPr>
           <a:xfrm>
-            <a:off x="411480" y="6547104"/>
+            <a:off x="548640" y="6547104"/>
             <a:ext cx="274320" cy="274320"/>
           </a:xfrm>
           <a:prstGeom prst="rect">
@@ -9519,7 +10479,7 @@
         </p:nvSpPr>
         <p:spPr>
           <a:xfrm>
-            <a:off x="749808" y="6528816"/>
+            <a:off x="886968" y="6528816"/>
             <a:ext cx="6400800" cy="310896"/>
           </a:xfrm>
           <a:prstGeom prst="rect">
@@ -9559,7 +10519,7 @@
         <p:spPr>
           <a:xfrm>
             <a:off x="7132320" y="6528816"/>
-            <a:ext cx="4663440" cy="310896"/>
+            <a:ext cx="4023360" cy="310896"/>
           </a:xfrm>
           <a:prstGeom prst="rect">
             <a:avLst/>
@@ -9597,7 +10557,7 @@
         </p:nvSpPr>
         <p:spPr>
           <a:xfrm>
-            <a:off x="411480" y="384048"/>
+            <a:off x="548640" y="384048"/>
             <a:ext cx="82296" cy="658368"/>
           </a:xfrm>
           <a:prstGeom prst="rect">
@@ -9617,7 +10577,7 @@
         </p:nvSpPr>
         <p:spPr>
           <a:xfrm>
-            <a:off x="640080" y="292608"/>
+            <a:off x="777240" y="292608"/>
             <a:ext cx="10972800" cy="274320"/>
           </a:xfrm>
           <a:prstGeom prst="rect">
@@ -9656,8 +10616,8 @@
         </p:nvSpPr>
         <p:spPr>
           <a:xfrm>
-            <a:off x="640080" y="530352"/>
-            <a:ext cx="11155680" cy="566928"/>
+            <a:off x="777240" y="530352"/>
+            <a:ext cx="10881360" cy="566928"/>
           </a:xfrm>
           <a:prstGeom prst="rect">
             <a:avLst/>
@@ -9697,12 +10657,12 @@
         </p:nvSpPr>
         <p:spPr>
           <a:xfrm>
-            <a:off x="411480" y="1325880"/>
-            <a:ext cx="3611880" cy="4937760"/>
+            <a:off x="548640" y="1325880"/>
+            <a:ext cx="3514344" cy="4937760"/>
           </a:xfrm>
           <a:prstGeom prst="roundRect">
             <a:avLst>
-              <a:gd name="adj" fmla="val 2025"/>
+              <a:gd name="adj" fmla="val 2082"/>
             </a:avLst>
           </a:prstGeom>
           <a:solidFill>
@@ -9731,8 +10691,8 @@
         </p:nvSpPr>
         <p:spPr>
           <a:xfrm>
-            <a:off x="411480" y="1325880"/>
-            <a:ext cx="3611880" cy="109728"/>
+            <a:off x="548640" y="1325880"/>
+            <a:ext cx="3514344" cy="109728"/>
           </a:xfrm>
           <a:prstGeom prst="rect">
             <a:avLst/>
@@ -9751,8 +10711,8 @@
         </p:nvSpPr>
         <p:spPr>
           <a:xfrm>
-            <a:off x="685800" y="1554480"/>
-            <a:ext cx="3063240" cy="685800"/>
+            <a:off x="822960" y="1554480"/>
+            <a:ext cx="2965704" cy="685800"/>
           </a:xfrm>
           <a:prstGeom prst="rect">
             <a:avLst/>
@@ -9792,8 +10752,8 @@
         </p:nvSpPr>
         <p:spPr>
           <a:xfrm>
-            <a:off x="685800" y="2286000"/>
-            <a:ext cx="3063240" cy="3749040"/>
+            <a:off x="822960" y="2286000"/>
+            <a:ext cx="2965704" cy="3749040"/>
           </a:xfrm>
           <a:prstGeom prst="rect">
             <a:avLst/>
@@ -9814,7 +10774,7 @@
               <a:buNone/>
             </a:pPr>
             <a:r>
-              <a:rPr lang="en-US" sz="1400" dirty="0">
+              <a:rPr lang="en-US" sz="1700" dirty="0">
                 <a:solidFill>
                   <a:srgbClr val="1F2937"/>
                 </a:solidFill>
@@ -9824,7 +10784,7 @@
               </a:rPr>
               <a:t>1. Fundamentos (M0–M1)</a:t>
             </a:r>
-            <a:endParaRPr lang="en-US" sz="1400" dirty="0"/>
+            <a:endParaRPr lang="en-US" sz="1700" dirty="0"/>
           </a:p>
           <a:p>
             <a:pPr indent="0" marL="0">
@@ -9834,7 +10794,7 @@
               <a:buNone/>
             </a:pPr>
             <a:r>
-              <a:rPr lang="en-US" sz="1400" dirty="0">
+              <a:rPr lang="en-US" sz="1700" dirty="0">
                 <a:solidFill>
                   <a:srgbClr val="1F2937"/>
                 </a:solidFill>
@@ -9844,7 +10804,7 @@
               </a:rPr>
               <a:t>2. Regulação e negócio (M2–M3)</a:t>
             </a:r>
-            <a:endParaRPr lang="en-US" sz="1400" dirty="0"/>
+            <a:endParaRPr lang="en-US" sz="1700" dirty="0"/>
           </a:p>
           <a:p>
             <a:pPr indent="0" marL="0">
@@ -9854,7 +10814,7 @@
               <a:buNone/>
             </a:pPr>
             <a:r>
-              <a:rPr lang="en-US" sz="1400" dirty="0">
+              <a:rPr lang="en-US" sz="1700" dirty="0">
                 <a:solidFill>
                   <a:srgbClr val="1F2937"/>
                 </a:solidFill>
@@ -9864,7 +10824,7 @@
               </a:rPr>
               <a:t>3. Operação ponta a ponta (M4–M9)</a:t>
             </a:r>
-            <a:endParaRPr lang="en-US" sz="1400" dirty="0"/>
+            <a:endParaRPr lang="en-US" sz="1700" dirty="0"/>
           </a:p>
           <a:p>
             <a:pPr indent="0" marL="0">
@@ -9874,7 +10834,7 @@
               <a:buNone/>
             </a:pPr>
             <a:r>
-              <a:rPr lang="en-US" sz="1400" dirty="0">
+              <a:rPr lang="en-US" sz="1700" dirty="0">
                 <a:solidFill>
                   <a:srgbClr val="1F2937"/>
                 </a:solidFill>
@@ -9884,7 +10844,7 @@
               </a:rPr>
               <a:t>4. Gestão e estratégia (M10–M12)</a:t>
             </a:r>
-            <a:endParaRPr lang="en-US" sz="1400" dirty="0"/>
+            <a:endParaRPr lang="en-US" sz="1700" dirty="0"/>
           </a:p>
         </p:txBody>
       </p:sp>
@@ -9896,12 +10856,12 @@
         </p:nvSpPr>
         <p:spPr>
           <a:xfrm>
-            <a:off x="4297680" y="1325880"/>
-            <a:ext cx="3611880" cy="4937760"/>
+            <a:off x="4337304" y="1325880"/>
+            <a:ext cx="3514344" cy="4937760"/>
           </a:xfrm>
           <a:prstGeom prst="roundRect">
             <a:avLst>
-              <a:gd name="adj" fmla="val 2025"/>
+              <a:gd name="adj" fmla="val 2082"/>
             </a:avLst>
           </a:prstGeom>
           <a:solidFill>
@@ -9930,8 +10890,8 @@
         </p:nvSpPr>
         <p:spPr>
           <a:xfrm>
-            <a:off x="4297680" y="1325880"/>
-            <a:ext cx="3611880" cy="109728"/>
+            <a:off x="4337304" y="1325880"/>
+            <a:ext cx="3514344" cy="109728"/>
           </a:xfrm>
           <a:prstGeom prst="rect">
             <a:avLst/>
@@ -9950,8 +10910,8 @@
         </p:nvSpPr>
         <p:spPr>
           <a:xfrm>
-            <a:off x="4572000" y="1554480"/>
-            <a:ext cx="3063240" cy="685800"/>
+            <a:off x="4611624" y="1554480"/>
+            <a:ext cx="2965704" cy="685800"/>
           </a:xfrm>
           <a:prstGeom prst="rect">
             <a:avLst/>
@@ -9991,8 +10951,8 @@
         </p:nvSpPr>
         <p:spPr>
           <a:xfrm>
-            <a:off x="4572000" y="2286000"/>
-            <a:ext cx="3063240" cy="3749040"/>
+            <a:off x="4611624" y="2286000"/>
+            <a:ext cx="2965704" cy="3749040"/>
           </a:xfrm>
           <a:prstGeom prst="rect">
             <a:avLst/>
@@ -10057,12 +11017,12 @@
         </p:nvSpPr>
         <p:spPr>
           <a:xfrm>
-            <a:off x="8183880" y="1325880"/>
-            <a:ext cx="3611880" cy="4937760"/>
+            <a:off x="8125968" y="1325880"/>
+            <a:ext cx="3514344" cy="4937760"/>
           </a:xfrm>
           <a:prstGeom prst="roundRect">
             <a:avLst>
-              <a:gd name="adj" fmla="val 2025"/>
+              <a:gd name="adj" fmla="val 2082"/>
             </a:avLst>
           </a:prstGeom>
           <a:solidFill>
@@ -10091,8 +11051,8 @@
         </p:nvSpPr>
         <p:spPr>
           <a:xfrm>
-            <a:off x="8183880" y="1325880"/>
-            <a:ext cx="3611880" cy="109728"/>
+            <a:off x="8125968" y="1325880"/>
+            <a:ext cx="3514344" cy="109728"/>
           </a:xfrm>
           <a:prstGeom prst="rect">
             <a:avLst/>
@@ -10111,8 +11071,8 @@
         </p:nvSpPr>
         <p:spPr>
           <a:xfrm>
-            <a:off x="8458200" y="1554480"/>
-            <a:ext cx="3063240" cy="685800"/>
+            <a:off x="8400288" y="1554480"/>
+            <a:ext cx="2965704" cy="685800"/>
           </a:xfrm>
           <a:prstGeom prst="rect">
             <a:avLst/>
@@ -10152,8 +11112,8 @@
         </p:nvSpPr>
         <p:spPr>
           <a:xfrm>
-            <a:off x="8458200" y="2286000"/>
-            <a:ext cx="3063240" cy="3749040"/>
+            <a:off x="8400288" y="2286000"/>
+            <a:ext cx="2965704" cy="3749040"/>
           </a:xfrm>
           <a:prstGeom prst="rect">
             <a:avLst/>
@@ -10228,6 +11188,54 @@
               <a:t>Projeto final = sua empresa operando</a:t>
             </a:r>
             <a:endParaRPr lang="en-US" sz="1700" dirty="0"/>
+          </a:p>
+        </p:txBody>
+      </p:sp>
+      <p:sp>
+        <p:nvSpPr>
+          <p:cNvPr id="25" name="Slide Number Placeholder 0"/>
+          <p:cNvSpPr>
+            <a:spLocks noGrp="1"/>
+          </p:cNvSpPr>
+          <p:nvPr>
+            <p:ph type="sldNum" sz="quarter" idx="4294967295"/>
+          </p:nvPr>
+        </p:nvSpPr>
+        <p:spPr>
+          <a:xfrm>
+            <a:off x="11292840" y="6556248"/>
+            <a:ext cx="548640" cy="256032"/>
+          </a:xfrm>
+          <a:prstGeom prst="rect">
+            <a:avLst/>
+          </a:prstGeom>
+          <a:extLst>
+            <a:ext uri="{C572A759-6A51-4108-AA02-DFA0A04FC94B}">
+              <ma14:wrappingTextBoxFlag xmlns:ma14="http://schemas.microsoft.com/office/mac/drawingml/2011/main" val="0"/>
+            </a:ext>
+          </a:extLst>
+        </p:spPr>
+        <p:txBody>
+          <a:bodyPr/>
+          <a:lstStyle>
+            <a:lvl1pPr>
+              <a:defRPr sz="900">
+                <a:solidFill>
+                  <a:srgbClr val="1B3A6B"/>
+                </a:solidFill>
+                <a:latin typeface="Arial"/>
+                <a:ea typeface="Arial"/>
+                <a:cs typeface="Arial"/>
+              </a:defRPr>
+            </a:lvl1pPr>
+          </a:lstStyle>
+          <a:p>
+            <a:pPr algn="r"/>
+            <a:fld id="{F7021451-1387-4CA6-816F-3879F97B5CBC}" type="slidenum">
+              <a:rPr b="1" lang="en-US"/>
+              <a:t>8</a:t>
+            </a:fld>
+            <a:endParaRPr lang="en-US"/>
           </a:p>
         </p:txBody>
       </p:sp>
@@ -10304,7 +11312,7 @@
         </p:blipFill>
         <p:spPr>
           <a:xfrm>
-            <a:off x="411480" y="6547104"/>
+            <a:off x="548640" y="6547104"/>
             <a:ext cx="274320" cy="274320"/>
           </a:xfrm>
           <a:prstGeom prst="rect">
@@ -10320,7 +11328,7 @@
         </p:nvSpPr>
         <p:spPr>
           <a:xfrm>
-            <a:off x="749808" y="6528816"/>
+            <a:off x="886968" y="6528816"/>
             <a:ext cx="6400800" cy="310896"/>
           </a:xfrm>
           <a:prstGeom prst="rect">
@@ -10360,7 +11368,7 @@
         <p:spPr>
           <a:xfrm>
             <a:off x="7132320" y="6528816"/>
-            <a:ext cx="4663440" cy="310896"/>
+            <a:ext cx="4023360" cy="310896"/>
           </a:xfrm>
           <a:prstGeom prst="rect">
             <a:avLst/>
@@ -10398,7 +11406,7 @@
         </p:nvSpPr>
         <p:spPr>
           <a:xfrm>
-            <a:off x="411480" y="384048"/>
+            <a:off x="548640" y="384048"/>
             <a:ext cx="82296" cy="658368"/>
           </a:xfrm>
           <a:prstGeom prst="rect">
@@ -10418,7 +11426,7 @@
         </p:nvSpPr>
         <p:spPr>
           <a:xfrm>
-            <a:off x="640080" y="292608"/>
+            <a:off x="777240" y="292608"/>
             <a:ext cx="10972800" cy="274320"/>
           </a:xfrm>
           <a:prstGeom prst="rect">
@@ -10457,8 +11465,8 @@
         </p:nvSpPr>
         <p:spPr>
           <a:xfrm>
-            <a:off x="640080" y="530352"/>
-            <a:ext cx="11155680" cy="566928"/>
+            <a:off x="777240" y="530352"/>
+            <a:ext cx="10881360" cy="566928"/>
           </a:xfrm>
           <a:prstGeom prst="rect">
             <a:avLst/>
@@ -10498,8 +11506,8 @@
         </p:nvSpPr>
         <p:spPr>
           <a:xfrm>
-            <a:off x="411480" y="1325880"/>
-            <a:ext cx="5577840" cy="2331720"/>
+            <a:off x="548640" y="1325880"/>
+            <a:ext cx="5431536" cy="2331720"/>
           </a:xfrm>
           <a:prstGeom prst="roundRect">
             <a:avLst>
@@ -10532,7 +11540,7 @@
         </p:nvSpPr>
         <p:spPr>
           <a:xfrm>
-            <a:off x="594360" y="1508760"/>
+            <a:off x="731520" y="1508760"/>
             <a:ext cx="457200" cy="457200"/>
           </a:xfrm>
           <a:prstGeom prst="ellipse">
@@ -10552,7 +11560,7 @@
         </p:nvSpPr>
         <p:spPr>
           <a:xfrm>
-            <a:off x="594360" y="1508760"/>
+            <a:off x="731520" y="1508760"/>
             <a:ext cx="457200" cy="457200"/>
           </a:xfrm>
           <a:prstGeom prst="rect">
@@ -10591,8 +11599,8 @@
         </p:nvSpPr>
         <p:spPr>
           <a:xfrm>
-            <a:off x="1188720" y="1435608"/>
-            <a:ext cx="4663440" cy="2112264"/>
+            <a:off x="1325880" y="1435608"/>
+            <a:ext cx="4517136" cy="2112264"/>
           </a:xfrm>
           <a:prstGeom prst="rect">
             <a:avLst/>
@@ -10632,8 +11640,8 @@
         </p:nvSpPr>
         <p:spPr>
           <a:xfrm>
-            <a:off x="6217920" y="1325880"/>
-            <a:ext cx="5577840" cy="2331720"/>
+            <a:off x="6208776" y="1325880"/>
+            <a:ext cx="5431536" cy="2331720"/>
           </a:xfrm>
           <a:prstGeom prst="roundRect">
             <a:avLst>
@@ -10666,7 +11674,7 @@
         </p:nvSpPr>
         <p:spPr>
           <a:xfrm>
-            <a:off x="6400800" y="1508760"/>
+            <a:off x="6391656" y="1508760"/>
             <a:ext cx="457200" cy="457200"/>
           </a:xfrm>
           <a:prstGeom prst="ellipse">
@@ -10686,7 +11694,7 @@
         </p:nvSpPr>
         <p:spPr>
           <a:xfrm>
-            <a:off x="6400800" y="1508760"/>
+            <a:off x="6391656" y="1508760"/>
             <a:ext cx="457200" cy="457200"/>
           </a:xfrm>
           <a:prstGeom prst="rect">
@@ -10725,8 +11733,8 @@
         </p:nvSpPr>
         <p:spPr>
           <a:xfrm>
-            <a:off x="6995160" y="1435608"/>
-            <a:ext cx="4663440" cy="2112264"/>
+            <a:off x="6986016" y="1435608"/>
+            <a:ext cx="4517136" cy="2112264"/>
           </a:xfrm>
           <a:prstGeom prst="rect">
             <a:avLst/>
@@ -10766,8 +11774,8 @@
         </p:nvSpPr>
         <p:spPr>
           <a:xfrm>
-            <a:off x="411480" y="3886200"/>
-            <a:ext cx="5577840" cy="2331720"/>
+            <a:off x="548640" y="3886200"/>
+            <a:ext cx="5431536" cy="2331720"/>
           </a:xfrm>
           <a:prstGeom prst="roundRect">
             <a:avLst>
@@ -10800,7 +11808,7 @@
         </p:nvSpPr>
         <p:spPr>
           <a:xfrm>
-            <a:off x="594360" y="4069080"/>
+            <a:off x="731520" y="4069080"/>
             <a:ext cx="457200" cy="457200"/>
           </a:xfrm>
           <a:prstGeom prst="ellipse">
@@ -10820,7 +11828,7 @@
         </p:nvSpPr>
         <p:spPr>
           <a:xfrm>
-            <a:off x="594360" y="4069080"/>
+            <a:off x="731520" y="4069080"/>
             <a:ext cx="457200" cy="457200"/>
           </a:xfrm>
           <a:prstGeom prst="rect">
@@ -10859,8 +11867,8 @@
         </p:nvSpPr>
         <p:spPr>
           <a:xfrm>
-            <a:off x="1188720" y="3995928"/>
-            <a:ext cx="4663440" cy="2112264"/>
+            <a:off x="1325880" y="3995928"/>
+            <a:ext cx="4517136" cy="2112264"/>
           </a:xfrm>
           <a:prstGeom prst="rect">
             <a:avLst/>
@@ -10900,8 +11908,8 @@
         </p:nvSpPr>
         <p:spPr>
           <a:xfrm>
-            <a:off x="6217920" y="3886200"/>
-            <a:ext cx="5577840" cy="2331720"/>
+            <a:off x="6208776" y="3886200"/>
+            <a:ext cx="5431536" cy="2331720"/>
           </a:xfrm>
           <a:prstGeom prst="roundRect">
             <a:avLst>
@@ -10934,7 +11942,7 @@
         </p:nvSpPr>
         <p:spPr>
           <a:xfrm>
-            <a:off x="6400800" y="4069080"/>
+            <a:off x="6391656" y="4069080"/>
             <a:ext cx="457200" cy="457200"/>
           </a:xfrm>
           <a:prstGeom prst="ellipse">
@@ -10954,7 +11962,7 @@
         </p:nvSpPr>
         <p:spPr>
           <a:xfrm>
-            <a:off x="6400800" y="4069080"/>
+            <a:off x="6391656" y="4069080"/>
             <a:ext cx="457200" cy="457200"/>
           </a:xfrm>
           <a:prstGeom prst="rect">
@@ -10993,8 +12001,8 @@
         </p:nvSpPr>
         <p:spPr>
           <a:xfrm>
-            <a:off x="6995160" y="3995928"/>
-            <a:ext cx="4663440" cy="2112264"/>
+            <a:off x="6986016" y="3995928"/>
+            <a:ext cx="4517136" cy="2112264"/>
           </a:xfrm>
           <a:prstGeom prst="rect">
             <a:avLst/>
@@ -11023,6 +12031,54 @@
               <a:t>- Use a calculadora e os modelos no seu negócio real</a:t>
             </a:r>
             <a:endParaRPr lang="en-US" sz="1800" dirty="0"/>
+          </a:p>
+        </p:txBody>
+      </p:sp>
+      <p:sp>
+        <p:nvSpPr>
+          <p:cNvPr id="25" name="Slide Number Placeholder 0"/>
+          <p:cNvSpPr>
+            <a:spLocks noGrp="1"/>
+          </p:cNvSpPr>
+          <p:nvPr>
+            <p:ph type="sldNum" sz="quarter" idx="4294967295"/>
+          </p:nvPr>
+        </p:nvSpPr>
+        <p:spPr>
+          <a:xfrm>
+            <a:off x="11292840" y="6556248"/>
+            <a:ext cx="548640" cy="256032"/>
+          </a:xfrm>
+          <a:prstGeom prst="rect">
+            <a:avLst/>
+          </a:prstGeom>
+          <a:extLst>
+            <a:ext uri="{C572A759-6A51-4108-AA02-DFA0A04FC94B}">
+              <ma14:wrappingTextBoxFlag xmlns:ma14="http://schemas.microsoft.com/office/mac/drawingml/2011/main" val="0"/>
+            </a:ext>
+          </a:extLst>
+        </p:spPr>
+        <p:txBody>
+          <a:bodyPr/>
+          <a:lstStyle>
+            <a:lvl1pPr>
+              <a:defRPr sz="900">
+                <a:solidFill>
+                  <a:srgbClr val="1B3A6B"/>
+                </a:solidFill>
+                <a:latin typeface="Arial"/>
+                <a:ea typeface="Arial"/>
+                <a:cs typeface="Arial"/>
+              </a:defRPr>
+            </a:lvl1pPr>
+          </a:lstStyle>
+          <a:p>
+            <a:pPr algn="r"/>
+            <a:fld id="{F7021451-1387-4CA6-816F-3879F97B5CBC}" type="slidenum">
+              <a:rPr b="1" lang="en-US"/>
+              <a:t>9</a:t>
+            </a:fld>
+            <a:endParaRPr lang="en-US"/>
           </a:p>
         </p:txBody>
       </p:sp>

</xml_diff>